<commit_message>
chore(deck): local render pass, layout and chart fixes
Co-Authored-By: Claude Opus 5.5 <noreply@anthropic.com>
Claude-Session: https://claude.ai/code/session_016QENrZoUiH2GSA5C6QaHnv
</commit_message>
<xml_diff>
--- a/deck/out/favoured-banks.pptx
+++ b/deck/out/favoured-banks.pptx
@@ -5596,8 +5596,8 @@
         </p:nvSpPr>
         <p:spPr>
           <a:xfrm>
-            <a:off x="0" y="2857500"/>
-            <a:ext cx="12192000" cy="952500"/>
+            <a:off x="0" y="2794000"/>
+            <a:ext cx="12192000" cy="990600"/>
           </a:xfrm>
           <a:prstGeom prst="rect">
             <a:avLst/>
@@ -5635,7 +5635,7 @@
         </p:nvSpPr>
         <p:spPr>
           <a:xfrm>
-            <a:off x="0" y="3810000"/>
+            <a:off x="0" y="3937000"/>
             <a:ext cx="12192000" cy="317500"/>
           </a:xfrm>
           <a:prstGeom prst="rect">
@@ -5674,7 +5674,7 @@
         </p:nvCxnSpPr>
         <p:spPr>
           <a:xfrm>
-            <a:off x="5588000" y="4445000"/>
+            <a:off x="5588000" y="4572000"/>
             <a:ext cx="1016000" cy="0"/>
           </a:xfrm>
           <a:prstGeom prst="line">
@@ -5709,7 +5709,7 @@
         </p:nvCxnSpPr>
         <p:spPr>
           <a:xfrm>
-            <a:off x="5588000" y="4521200"/>
+            <a:off x="5588000" y="4648200"/>
             <a:ext cx="1016000" cy="0"/>
           </a:xfrm>
           <a:prstGeom prst="line">
@@ -5859,7 +5859,7 @@
         <p:spPr>
           <a:xfrm>
             <a:off x="762000" y="1206500"/>
-            <a:ext cx="3937000" cy="1717040"/>
+            <a:ext cx="3810000" cy="1717040"/>
           </a:xfrm>
           <a:prstGeom prst="rect">
             <a:avLst/>
@@ -5898,7 +5898,7 @@
         <p:spPr>
           <a:xfrm>
             <a:off x="762000" y="3088640"/>
-            <a:ext cx="3937000" cy="462280"/>
+            <a:ext cx="3810000" cy="462280"/>
           </a:xfrm>
           <a:prstGeom prst="rect">
             <a:avLst/>
@@ -5944,8 +5944,8 @@
         </p:blipFill>
         <p:spPr>
           <a:xfrm>
-            <a:off x="5016500" y="1206500"/>
-            <a:ext cx="6413500" cy="3478508"/>
+            <a:off x="4889500" y="1540144"/>
+            <a:ext cx="6731000" cy="3650711"/>
           </a:xfrm>
           <a:prstGeom prst="rect">
             <a:avLst/>
@@ -6231,7 +6231,7 @@
         <p:spPr>
           <a:xfrm>
             <a:off x="762000" y="1206500"/>
-            <a:ext cx="3937000" cy="858520"/>
+            <a:ext cx="3810000" cy="858520"/>
           </a:xfrm>
           <a:prstGeom prst="rect">
             <a:avLst/>
@@ -6270,7 +6270,7 @@
         <p:spPr>
           <a:xfrm>
             <a:off x="762000" y="2230120"/>
-            <a:ext cx="3937000" cy="462280"/>
+            <a:ext cx="3810000" cy="462280"/>
           </a:xfrm>
           <a:prstGeom prst="rect">
             <a:avLst/>
@@ -6309,7 +6309,7 @@
         <p:spPr>
           <a:xfrm>
             <a:off x="762000" y="2781300"/>
-            <a:ext cx="3937000" cy="462280"/>
+            <a:ext cx="3810000" cy="462280"/>
           </a:xfrm>
           <a:prstGeom prst="rect">
             <a:avLst/>
@@ -6355,8 +6355,8 @@
         </p:blipFill>
         <p:spPr>
           <a:xfrm>
-            <a:off x="5016500" y="1206500"/>
-            <a:ext cx="6413500" cy="3804618"/>
+            <a:off x="4889500" y="1369016"/>
+            <a:ext cx="6731000" cy="3992966"/>
           </a:xfrm>
           <a:prstGeom prst="rect">
             <a:avLst/>
@@ -7386,7 +7386,7 @@
         <p:spPr>
           <a:xfrm>
             <a:off x="762000" y="1206500"/>
-            <a:ext cx="3937000" cy="858520"/>
+            <a:ext cx="3810000" cy="1287780"/>
           </a:xfrm>
           <a:prstGeom prst="rect">
             <a:avLst/>
@@ -7424,8 +7424,8 @@
         </p:nvSpPr>
         <p:spPr>
           <a:xfrm>
-            <a:off x="762000" y="2230120"/>
-            <a:ext cx="3937000" cy="231140"/>
+            <a:off x="762000" y="2659380"/>
+            <a:ext cx="3810000" cy="462280"/>
           </a:xfrm>
           <a:prstGeom prst="rect">
             <a:avLst/>
@@ -7463,8 +7463,8 @@
         </p:nvSpPr>
         <p:spPr>
           <a:xfrm>
-            <a:off x="762000" y="2550160"/>
-            <a:ext cx="3937000" cy="693420"/>
+            <a:off x="762000" y="3210560"/>
+            <a:ext cx="3810000" cy="924560"/>
           </a:xfrm>
           <a:prstGeom prst="rect">
             <a:avLst/>
@@ -7510,8 +7510,8 @@
         </p:blipFill>
         <p:spPr>
           <a:xfrm>
-            <a:off x="5016500" y="1206500"/>
-            <a:ext cx="6413500" cy="3478508"/>
+            <a:off x="4889500" y="1540144"/>
+            <a:ext cx="6731000" cy="3650711"/>
           </a:xfrm>
           <a:prstGeom prst="rect">
             <a:avLst/>
@@ -8169,7 +8169,7 @@
         <p:spPr>
           <a:xfrm>
             <a:off x="762000" y="1206500"/>
-            <a:ext cx="3937000" cy="858520"/>
+            <a:ext cx="3810000" cy="858520"/>
           </a:xfrm>
           <a:prstGeom prst="rect">
             <a:avLst/>
@@ -8208,7 +8208,7 @@
         <p:spPr>
           <a:xfrm>
             <a:off x="762000" y="2230120"/>
-            <a:ext cx="3937000" cy="462280"/>
+            <a:ext cx="3810000" cy="462280"/>
           </a:xfrm>
           <a:prstGeom prst="rect">
             <a:avLst/>
@@ -8247,7 +8247,7 @@
         <p:spPr>
           <a:xfrm>
             <a:off x="762000" y="2781300"/>
-            <a:ext cx="3937000" cy="693420"/>
+            <a:ext cx="3810000" cy="693420"/>
           </a:xfrm>
           <a:prstGeom prst="rect">
             <a:avLst/>
@@ -8293,8 +8293,8 @@
         </p:blipFill>
         <p:spPr>
           <a:xfrm>
-            <a:off x="5016500" y="1206500"/>
-            <a:ext cx="6413500" cy="2798618"/>
+            <a:off x="4889500" y="1896918"/>
+            <a:ext cx="6731000" cy="2937163"/>
           </a:xfrm>
           <a:prstGeom prst="rect">
             <a:avLst/>
@@ -8530,8 +8530,8 @@
         </p:nvSpPr>
         <p:spPr>
           <a:xfrm>
-            <a:off x="0" y="2857500"/>
-            <a:ext cx="12192000" cy="952500"/>
+            <a:off x="0" y="2794000"/>
+            <a:ext cx="12192000" cy="990600"/>
           </a:xfrm>
           <a:prstGeom prst="rect">
             <a:avLst/>
@@ -8569,7 +8569,7 @@
         </p:nvSpPr>
         <p:spPr>
           <a:xfrm>
-            <a:off x="0" y="3810000"/>
+            <a:off x="0" y="3937000"/>
             <a:ext cx="12192000" cy="317500"/>
           </a:xfrm>
           <a:prstGeom prst="rect">
@@ -8608,7 +8608,7 @@
         </p:nvCxnSpPr>
         <p:spPr>
           <a:xfrm>
-            <a:off x="5588000" y="4445000"/>
+            <a:off x="5588000" y="4572000"/>
             <a:ext cx="1016000" cy="0"/>
           </a:xfrm>
           <a:prstGeom prst="line">
@@ -8643,7 +8643,7 @@
         </p:nvCxnSpPr>
         <p:spPr>
           <a:xfrm>
-            <a:off x="5588000" y="4521200"/>
+            <a:off x="5588000" y="4648200"/>
             <a:ext cx="1016000" cy="0"/>
           </a:xfrm>
           <a:prstGeom prst="line">
@@ -9037,7 +9037,7 @@
                 </a:solidFill>
                 <a:latin typeface="IBM Plex Mono"/>
               </a:rPr>
-              <a:t>source: data/processed/domain_type_mix.csv</a:t>
+              <a:t>source: data/processed/domain_type_mix.csv  ·  each share rounded on its own, so sums can differ by 1 point</a:t>
             </a:r>
           </a:p>
         </p:txBody>
@@ -9204,7 +9204,7 @@
         <p:spPr>
           <a:xfrm>
             <a:off x="762000" y="1826260"/>
-            <a:ext cx="9525000" cy="726440"/>
+            <a:ext cx="9525000" cy="1089660"/>
           </a:xfrm>
           <a:prstGeom prst="rect">
             <a:avLst/>
@@ -9242,7 +9242,7 @@
         </p:nvSpPr>
         <p:spPr>
           <a:xfrm>
-            <a:off x="762000" y="2616200"/>
+            <a:off x="762000" y="2979420"/>
             <a:ext cx="9525000" cy="462280"/>
           </a:xfrm>
           <a:prstGeom prst="rect">
@@ -9281,7 +9281,7 @@
         </p:nvSpPr>
         <p:spPr>
           <a:xfrm>
-            <a:off x="762000" y="3510279"/>
+            <a:off x="762000" y="3873500"/>
             <a:ext cx="88900" cy="88900"/>
           </a:xfrm>
           <a:prstGeom prst="rect">
@@ -9325,7 +9325,7 @@
         </p:nvSpPr>
         <p:spPr>
           <a:xfrm>
-            <a:off x="952500" y="3459479"/>
+            <a:off x="952500" y="3822700"/>
             <a:ext cx="3810000" cy="190500"/>
           </a:xfrm>
           <a:prstGeom prst="rect">
@@ -9364,8 +9364,8 @@
         </p:nvSpPr>
         <p:spPr>
           <a:xfrm>
-            <a:off x="762000" y="3776979"/>
-            <a:ext cx="4318000" cy="1181100"/>
+            <a:off x="762000" y="4140200"/>
+            <a:ext cx="4318000" cy="1188720"/>
           </a:xfrm>
           <a:prstGeom prst="rect">
             <a:avLst/>
@@ -9435,7 +9435,7 @@
         </p:nvSpPr>
         <p:spPr>
           <a:xfrm>
-            <a:off x="5588000" y="3510279"/>
+            <a:off x="5588000" y="3873500"/>
             <a:ext cx="88900" cy="88900"/>
           </a:xfrm>
           <a:prstGeom prst="rect">
@@ -9479,7 +9479,7 @@
         </p:nvSpPr>
         <p:spPr>
           <a:xfrm>
-            <a:off x="5778500" y="3459479"/>
+            <a:off x="5778500" y="3822700"/>
             <a:ext cx="3810000" cy="190500"/>
           </a:xfrm>
           <a:prstGeom prst="rect">
@@ -9518,8 +9518,8 @@
         </p:nvSpPr>
         <p:spPr>
           <a:xfrm>
-            <a:off x="5588000" y="3776979"/>
-            <a:ext cx="4318000" cy="1181100"/>
+            <a:off x="5588000" y="4140200"/>
+            <a:ext cx="4318000" cy="1188720"/>
           </a:xfrm>
           <a:prstGeom prst="rect">
             <a:avLst/>
@@ -9860,7 +9860,7 @@
         <p:spPr>
           <a:xfrm>
             <a:off x="762000" y="1206500"/>
-            <a:ext cx="3937000" cy="858520"/>
+            <a:ext cx="3810000" cy="858520"/>
           </a:xfrm>
           <a:prstGeom prst="rect">
             <a:avLst/>
@@ -9899,7 +9899,7 @@
         <p:spPr>
           <a:xfrm>
             <a:off x="762000" y="2230120"/>
-            <a:ext cx="3937000" cy="693420"/>
+            <a:ext cx="3810000" cy="693420"/>
           </a:xfrm>
           <a:prstGeom prst="rect">
             <a:avLst/>
@@ -9938,7 +9938,7 @@
         <p:spPr>
           <a:xfrm>
             <a:off x="762000" y="3012440"/>
-            <a:ext cx="3937000" cy="693420"/>
+            <a:ext cx="3810000" cy="924560"/>
           </a:xfrm>
           <a:prstGeom prst="rect">
             <a:avLst/>
@@ -9984,8 +9984,8 @@
         </p:blipFill>
         <p:spPr>
           <a:xfrm>
-            <a:off x="5016500" y="1206500"/>
-            <a:ext cx="6413500" cy="3265054"/>
+            <a:off x="4889500" y="1652154"/>
+            <a:ext cx="6731000" cy="3426690"/>
           </a:xfrm>
           <a:prstGeom prst="rect">
             <a:avLst/>
@@ -10310,7 +10310,7 @@
         <p:spPr>
           <a:xfrm>
             <a:off x="762000" y="1699260"/>
-            <a:ext cx="8572500" cy="462280"/>
+            <a:ext cx="8572500" cy="231140"/>
           </a:xfrm>
           <a:prstGeom prst="rect">
             <a:avLst/>
@@ -10356,8 +10356,8 @@
         </p:blipFill>
         <p:spPr>
           <a:xfrm>
-            <a:off x="1864360" y="2275840"/>
-            <a:ext cx="8463279" cy="3324859"/>
+            <a:off x="1570181" y="2044700"/>
+            <a:ext cx="9051636" cy="3556000"/>
           </a:xfrm>
           <a:prstGeom prst="rect">
             <a:avLst/>
@@ -11054,7 +11054,7 @@
         <p:spPr>
           <a:xfrm>
             <a:off x="762000" y="1206500"/>
-            <a:ext cx="3937000" cy="858520"/>
+            <a:ext cx="3810000" cy="858520"/>
           </a:xfrm>
           <a:prstGeom prst="rect">
             <a:avLst/>
@@ -11093,7 +11093,7 @@
         <p:spPr>
           <a:xfrm>
             <a:off x="762000" y="2230120"/>
-            <a:ext cx="3937000" cy="462280"/>
+            <a:ext cx="3810000" cy="462280"/>
           </a:xfrm>
           <a:prstGeom prst="rect">
             <a:avLst/>
@@ -11139,8 +11139,8 @@
         </p:blipFill>
         <p:spPr>
           <a:xfrm>
-            <a:off x="5016500" y="1206500"/>
-            <a:ext cx="6413500" cy="2098963"/>
+            <a:off x="4889500" y="2264063"/>
+            <a:ext cx="6731000" cy="2202872"/>
           </a:xfrm>
           <a:prstGeom prst="rect">
             <a:avLst/>
@@ -11426,7 +11426,7 @@
         <p:spPr>
           <a:xfrm>
             <a:off x="762000" y="1206500"/>
-            <a:ext cx="3937000" cy="1287780"/>
+            <a:ext cx="3810000" cy="1717040"/>
           </a:xfrm>
           <a:prstGeom prst="rect">
             <a:avLst/>
@@ -11464,8 +11464,8 @@
         </p:nvSpPr>
         <p:spPr>
           <a:xfrm>
-            <a:off x="762000" y="2659380"/>
-            <a:ext cx="3937000" cy="693420"/>
+            <a:off x="762000" y="3088640"/>
+            <a:ext cx="3810000" cy="693420"/>
           </a:xfrm>
           <a:prstGeom prst="rect">
             <a:avLst/>
@@ -11503,8 +11503,8 @@
         </p:nvSpPr>
         <p:spPr>
           <a:xfrm>
-            <a:off x="762000" y="3441700"/>
-            <a:ext cx="3937000" cy="462280"/>
+            <a:off x="762000" y="3870960"/>
+            <a:ext cx="3810000" cy="462280"/>
           </a:xfrm>
           <a:prstGeom prst="rect">
             <a:avLst/>
@@ -11550,8 +11550,8 @@
         </p:blipFill>
         <p:spPr>
           <a:xfrm>
-            <a:off x="5016500" y="1206500"/>
-            <a:ext cx="6413500" cy="3261101"/>
+            <a:off x="4889500" y="1654228"/>
+            <a:ext cx="6731000" cy="3422542"/>
           </a:xfrm>
           <a:prstGeom prst="rect">
             <a:avLst/>
@@ -11837,7 +11837,7 @@
         <p:spPr>
           <a:xfrm>
             <a:off x="762000" y="1206500"/>
-            <a:ext cx="3937000" cy="1287780"/>
+            <a:ext cx="3810000" cy="1287780"/>
           </a:xfrm>
           <a:prstGeom prst="rect">
             <a:avLst/>
@@ -11862,7 +11862,7 @@
                 </a:solidFill>
                 <a:latin typeface="Work Sans"/>
               </a:rPr>
-              <a:t>Gemini's dead links come from links it wrapped in a Google search</a:t>
+              <a:t>Gemini's dead links all sit behind a Google redirect</a:t>
             </a:r>
           </a:p>
         </p:txBody>
@@ -11876,7 +11876,7 @@
         <p:spPr>
           <a:xfrm>
             <a:off x="762000" y="2659380"/>
-            <a:ext cx="3937000" cy="693420"/>
+            <a:ext cx="3810000" cy="693420"/>
           </a:xfrm>
           <a:prstGeom prst="rect">
             <a:avLst/>
@@ -11915,7 +11915,7 @@
         <p:spPr>
           <a:xfrm>
             <a:off x="762000" y="3441700"/>
-            <a:ext cx="3937000" cy="693420"/>
+            <a:ext cx="3810000" cy="693420"/>
           </a:xfrm>
           <a:prstGeom prst="rect">
             <a:avLst/>
@@ -11961,8 +11961,8 @@
         </p:blipFill>
         <p:spPr>
           <a:xfrm>
-            <a:off x="5016500" y="1206500"/>
-            <a:ext cx="6413500" cy="2065364"/>
+            <a:off x="4889500" y="2281694"/>
+            <a:ext cx="6731000" cy="2167610"/>
           </a:xfrm>
           <a:prstGeom prst="rect">
             <a:avLst/>
@@ -12248,7 +12248,7 @@
         <p:spPr>
           <a:xfrm>
             <a:off x="762000" y="1206500"/>
-            <a:ext cx="3937000" cy="858520"/>
+            <a:ext cx="3810000" cy="858520"/>
           </a:xfrm>
           <a:prstGeom prst="rect">
             <a:avLst/>
@@ -12287,7 +12287,7 @@
         <p:spPr>
           <a:xfrm>
             <a:off x="762000" y="2230120"/>
-            <a:ext cx="3937000" cy="693420"/>
+            <a:ext cx="3810000" cy="693420"/>
           </a:xfrm>
           <a:prstGeom prst="rect">
             <a:avLst/>
@@ -12326,7 +12326,7 @@
         <p:spPr>
           <a:xfrm>
             <a:off x="762000" y="3012440"/>
-            <a:ext cx="3937000" cy="462280"/>
+            <a:ext cx="3810000" cy="462280"/>
           </a:xfrm>
           <a:prstGeom prst="rect">
             <a:avLst/>
@@ -12365,7 +12365,7 @@
         <p:spPr>
           <a:xfrm>
             <a:off x="762000" y="3563620"/>
-            <a:ext cx="3937000" cy="462280"/>
+            <a:ext cx="3810000" cy="693420"/>
           </a:xfrm>
           <a:prstGeom prst="rect">
             <a:avLst/>
@@ -12411,8 +12411,8 @@
         </p:blipFill>
         <p:spPr>
           <a:xfrm>
-            <a:off x="5016500" y="1206500"/>
-            <a:ext cx="6413500" cy="2826288"/>
+            <a:off x="4889500" y="1711271"/>
+            <a:ext cx="6731000" cy="3308457"/>
           </a:xfrm>
           <a:prstGeom prst="rect">
             <a:avLst/>
@@ -12648,8 +12648,8 @@
         </p:nvSpPr>
         <p:spPr>
           <a:xfrm>
-            <a:off x="0" y="2857500"/>
-            <a:ext cx="12192000" cy="952500"/>
+            <a:off x="0" y="2794000"/>
+            <a:ext cx="12192000" cy="990600"/>
           </a:xfrm>
           <a:prstGeom prst="rect">
             <a:avLst/>
@@ -12687,7 +12687,7 @@
         </p:nvSpPr>
         <p:spPr>
           <a:xfrm>
-            <a:off x="0" y="3810000"/>
+            <a:off x="0" y="3937000"/>
             <a:ext cx="12192000" cy="317500"/>
           </a:xfrm>
           <a:prstGeom prst="rect">
@@ -12726,7 +12726,7 @@
         </p:nvCxnSpPr>
         <p:spPr>
           <a:xfrm>
-            <a:off x="5588000" y="4445000"/>
+            <a:off x="5588000" y="4572000"/>
             <a:ext cx="1016000" cy="0"/>
           </a:xfrm>
           <a:prstGeom prst="line">
@@ -12761,7 +12761,7 @@
         </p:nvCxnSpPr>
         <p:spPr>
           <a:xfrm>
-            <a:off x="5588000" y="4521200"/>
+            <a:off x="5588000" y="4648200"/>
             <a:ext cx="1016000" cy="0"/>
           </a:xfrm>
           <a:prstGeom prst="line">
@@ -12911,7 +12911,7 @@
         <p:spPr>
           <a:xfrm>
             <a:off x="762000" y="1270000"/>
-            <a:ext cx="9525000" cy="495300"/>
+            <a:ext cx="10668000" cy="495300"/>
           </a:xfrm>
           <a:prstGeom prst="rect">
             <a:avLst/>
@@ -13571,7 +13571,7 @@
         <p:spPr>
           <a:xfrm>
             <a:off x="762000" y="1270000"/>
-            <a:ext cx="9525000" cy="990600"/>
+            <a:ext cx="10668000" cy="495300"/>
           </a:xfrm>
           <a:prstGeom prst="rect">
             <a:avLst/>
@@ -13609,7 +13609,7 @@
         </p:nvSpPr>
         <p:spPr>
           <a:xfrm>
-            <a:off x="762000" y="2501900"/>
+            <a:off x="762000" y="2006600"/>
             <a:ext cx="571500" cy="215900"/>
           </a:xfrm>
           <a:prstGeom prst="rect">
@@ -13648,27 +13648,27 @@
         </p:nvSpPr>
         <p:spPr>
           <a:xfrm>
-            <a:off x="1460500" y="2476500"/>
-            <a:ext cx="8636000" cy="561340"/>
-          </a:xfrm>
-          <a:prstGeom prst="rect">
-            <a:avLst/>
-          </a:prstGeom>
-          <a:noFill/>
-        </p:spPr>
-        <p:txBody>
-          <a:bodyPr wrap="square" lIns="0" rIns="0" tIns="0" bIns="0" anchor="t">
-            <a:spAutoFit/>
-          </a:bodyPr>
-          <a:lstStyle/>
-          <a:p>
-            <a:pPr algn="l">
-              <a:lnSpc>
-                <a:spcPct val="115000"/>
-              </a:lnSpc>
-            </a:pPr>
-            <a:r>
-              <a:rPr sz="1700" b="0">
+            <a:off x="1460500" y="1981200"/>
+            <a:ext cx="8636000" cy="264160"/>
+          </a:xfrm>
+          <a:prstGeom prst="rect">
+            <a:avLst/>
+          </a:prstGeom>
+          <a:noFill/>
+        </p:spPr>
+        <p:txBody>
+          <a:bodyPr wrap="square" lIns="0" rIns="0" tIns="0" bIns="0" anchor="t">
+            <a:spAutoFit/>
+          </a:bodyPr>
+          <a:lstStyle/>
+          <a:p>
+            <a:pPr algn="l">
+              <a:lnSpc>
+                <a:spcPct val="115000"/>
+              </a:lnSpc>
+            </a:pPr>
+            <a:r>
+              <a:rPr sz="1600" b="0">
                 <a:solidFill>
                   <a:srgbClr val="ECE7DD"/>
                 </a:solidFill>
@@ -13687,7 +13687,7 @@
         </p:nvSpPr>
         <p:spPr>
           <a:xfrm>
-            <a:off x="762000" y="3202940"/>
+            <a:off x="762000" y="2397760"/>
             <a:ext cx="571500" cy="215900"/>
           </a:xfrm>
           <a:prstGeom prst="rect">
@@ -13726,27 +13726,27 @@
         </p:nvSpPr>
         <p:spPr>
           <a:xfrm>
-            <a:off x="1460500" y="3177540"/>
-            <a:ext cx="8636000" cy="280670"/>
-          </a:xfrm>
-          <a:prstGeom prst="rect">
-            <a:avLst/>
-          </a:prstGeom>
-          <a:noFill/>
-        </p:spPr>
-        <p:txBody>
-          <a:bodyPr wrap="square" lIns="0" rIns="0" tIns="0" bIns="0" anchor="t">
-            <a:spAutoFit/>
-          </a:bodyPr>
-          <a:lstStyle/>
-          <a:p>
-            <a:pPr algn="l">
-              <a:lnSpc>
-                <a:spcPct val="115000"/>
-              </a:lnSpc>
-            </a:pPr>
-            <a:r>
-              <a:rPr sz="1700" b="0">
+            <a:off x="1460500" y="2372360"/>
+            <a:ext cx="8636000" cy="264160"/>
+          </a:xfrm>
+          <a:prstGeom prst="rect">
+            <a:avLst/>
+          </a:prstGeom>
+          <a:noFill/>
+        </p:spPr>
+        <p:txBody>
+          <a:bodyPr wrap="square" lIns="0" rIns="0" tIns="0" bIns="0" anchor="t">
+            <a:spAutoFit/>
+          </a:bodyPr>
+          <a:lstStyle/>
+          <a:p>
+            <a:pPr algn="l">
+              <a:lnSpc>
+                <a:spcPct val="115000"/>
+              </a:lnSpc>
+            </a:pPr>
+            <a:r>
+              <a:rPr sz="1600" b="0">
                 <a:solidFill>
                   <a:srgbClr val="ECE7DD"/>
                 </a:solidFill>
@@ -13765,7 +13765,7 @@
         </p:nvSpPr>
         <p:spPr>
           <a:xfrm>
-            <a:off x="762000" y="3623310"/>
+            <a:off x="762000" y="2788920"/>
             <a:ext cx="571500" cy="215900"/>
           </a:xfrm>
           <a:prstGeom prst="rect">
@@ -13804,27 +13804,27 @@
         </p:nvSpPr>
         <p:spPr>
           <a:xfrm>
-            <a:off x="1460500" y="3597910"/>
-            <a:ext cx="8636000" cy="561340"/>
-          </a:xfrm>
-          <a:prstGeom prst="rect">
-            <a:avLst/>
-          </a:prstGeom>
-          <a:noFill/>
-        </p:spPr>
-        <p:txBody>
-          <a:bodyPr wrap="square" lIns="0" rIns="0" tIns="0" bIns="0" anchor="t">
-            <a:spAutoFit/>
-          </a:bodyPr>
-          <a:lstStyle/>
-          <a:p>
-            <a:pPr algn="l">
-              <a:lnSpc>
-                <a:spcPct val="115000"/>
-              </a:lnSpc>
-            </a:pPr>
-            <a:r>
-              <a:rPr sz="1700" b="0">
+            <a:off x="1460500" y="2763520"/>
+            <a:ext cx="8636000" cy="528320"/>
+          </a:xfrm>
+          <a:prstGeom prst="rect">
+            <a:avLst/>
+          </a:prstGeom>
+          <a:noFill/>
+        </p:spPr>
+        <p:txBody>
+          <a:bodyPr wrap="square" lIns="0" rIns="0" tIns="0" bIns="0" anchor="t">
+            <a:spAutoFit/>
+          </a:bodyPr>
+          <a:lstStyle/>
+          <a:p>
+            <a:pPr algn="l">
+              <a:lnSpc>
+                <a:spcPct val="115000"/>
+              </a:lnSpc>
+            </a:pPr>
+            <a:r>
+              <a:rPr sz="1600" b="0">
                 <a:solidFill>
                   <a:srgbClr val="ECE7DD"/>
                 </a:solidFill>
@@ -13843,7 +13843,7 @@
         </p:nvSpPr>
         <p:spPr>
           <a:xfrm>
-            <a:off x="762000" y="4324350"/>
+            <a:off x="762000" y="3444240"/>
             <a:ext cx="571500" cy="215900"/>
           </a:xfrm>
           <a:prstGeom prst="rect">
@@ -13882,27 +13882,27 @@
         </p:nvSpPr>
         <p:spPr>
           <a:xfrm>
-            <a:off x="1460500" y="4298950"/>
-            <a:ext cx="8636000" cy="561340"/>
-          </a:xfrm>
-          <a:prstGeom prst="rect">
-            <a:avLst/>
-          </a:prstGeom>
-          <a:noFill/>
-        </p:spPr>
-        <p:txBody>
-          <a:bodyPr wrap="square" lIns="0" rIns="0" tIns="0" bIns="0" anchor="t">
-            <a:spAutoFit/>
-          </a:bodyPr>
-          <a:lstStyle/>
-          <a:p>
-            <a:pPr algn="l">
-              <a:lnSpc>
-                <a:spcPct val="115000"/>
-              </a:lnSpc>
-            </a:pPr>
-            <a:r>
-              <a:rPr sz="1700" b="0">
+            <a:off x="1460500" y="3418840"/>
+            <a:ext cx="8636000" cy="264160"/>
+          </a:xfrm>
+          <a:prstGeom prst="rect">
+            <a:avLst/>
+          </a:prstGeom>
+          <a:noFill/>
+        </p:spPr>
+        <p:txBody>
+          <a:bodyPr wrap="square" lIns="0" rIns="0" tIns="0" bIns="0" anchor="t">
+            <a:spAutoFit/>
+          </a:bodyPr>
+          <a:lstStyle/>
+          <a:p>
+            <a:pPr algn="l">
+              <a:lnSpc>
+                <a:spcPct val="115000"/>
+              </a:lnSpc>
+            </a:pPr>
+            <a:r>
+              <a:rPr sz="1600" b="0">
                 <a:solidFill>
                   <a:srgbClr val="ECE7DD"/>
                 </a:solidFill>
@@ -13921,7 +13921,7 @@
         </p:nvSpPr>
         <p:spPr>
           <a:xfrm>
-            <a:off x="762000" y="5025390"/>
+            <a:off x="762000" y="3835400"/>
             <a:ext cx="571500" cy="215900"/>
           </a:xfrm>
           <a:prstGeom prst="rect">
@@ -13960,27 +13960,27 @@
         </p:nvSpPr>
         <p:spPr>
           <a:xfrm>
-            <a:off x="1460500" y="4999990"/>
-            <a:ext cx="8636000" cy="561340"/>
-          </a:xfrm>
-          <a:prstGeom prst="rect">
-            <a:avLst/>
-          </a:prstGeom>
-          <a:noFill/>
-        </p:spPr>
-        <p:txBody>
-          <a:bodyPr wrap="square" lIns="0" rIns="0" tIns="0" bIns="0" anchor="t">
-            <a:spAutoFit/>
-          </a:bodyPr>
-          <a:lstStyle/>
-          <a:p>
-            <a:pPr algn="l">
-              <a:lnSpc>
-                <a:spcPct val="115000"/>
-              </a:lnSpc>
-            </a:pPr>
-            <a:r>
-              <a:rPr sz="1700" b="0">
+            <a:off x="1460500" y="3810000"/>
+            <a:ext cx="8636000" cy="528320"/>
+          </a:xfrm>
+          <a:prstGeom prst="rect">
+            <a:avLst/>
+          </a:prstGeom>
+          <a:noFill/>
+        </p:spPr>
+        <p:txBody>
+          <a:bodyPr wrap="square" lIns="0" rIns="0" tIns="0" bIns="0" anchor="t">
+            <a:spAutoFit/>
+          </a:bodyPr>
+          <a:lstStyle/>
+          <a:p>
+            <a:pPr algn="l">
+              <a:lnSpc>
+                <a:spcPct val="115000"/>
+              </a:lnSpc>
+            </a:pPr>
+            <a:r>
+              <a:rPr sz="1600" b="0">
                 <a:solidFill>
                   <a:srgbClr val="ECE7DD"/>
                 </a:solidFill>
@@ -13999,7 +13999,7 @@
         </p:nvSpPr>
         <p:spPr>
           <a:xfrm>
-            <a:off x="762000" y="5726430"/>
+            <a:off x="762000" y="4490720"/>
             <a:ext cx="571500" cy="215900"/>
           </a:xfrm>
           <a:prstGeom prst="rect">
@@ -14038,27 +14038,27 @@
         </p:nvSpPr>
         <p:spPr>
           <a:xfrm>
-            <a:off x="1460500" y="5701030"/>
-            <a:ext cx="8636000" cy="561340"/>
-          </a:xfrm>
-          <a:prstGeom prst="rect">
-            <a:avLst/>
-          </a:prstGeom>
-          <a:noFill/>
-        </p:spPr>
-        <p:txBody>
-          <a:bodyPr wrap="square" lIns="0" rIns="0" tIns="0" bIns="0" anchor="t">
-            <a:spAutoFit/>
-          </a:bodyPr>
-          <a:lstStyle/>
-          <a:p>
-            <a:pPr algn="l">
-              <a:lnSpc>
-                <a:spcPct val="115000"/>
-              </a:lnSpc>
-            </a:pPr>
-            <a:r>
-              <a:rPr sz="1700" b="0">
+            <a:off x="1460500" y="4465320"/>
+            <a:ext cx="8636000" cy="528320"/>
+          </a:xfrm>
+          <a:prstGeom prst="rect">
+            <a:avLst/>
+          </a:prstGeom>
+          <a:noFill/>
+        </p:spPr>
+        <p:txBody>
+          <a:bodyPr wrap="square" lIns="0" rIns="0" tIns="0" bIns="0" anchor="t">
+            <a:spAutoFit/>
+          </a:bodyPr>
+          <a:lstStyle/>
+          <a:p>
+            <a:pPr algn="l">
+              <a:lnSpc>
+                <a:spcPct val="115000"/>
+              </a:lnSpc>
+            </a:pPr>
+            <a:r>
+              <a:rPr sz="1600" b="0">
                 <a:solidFill>
                   <a:srgbClr val="ECE7DD"/>
                 </a:solidFill>
@@ -14678,7 +14678,7 @@
         <p:spPr>
           <a:xfrm>
             <a:off x="762000" y="1270000"/>
-            <a:ext cx="9525000" cy="495300"/>
+            <a:ext cx="10668000" cy="495300"/>
           </a:xfrm>
           <a:prstGeom prst="rect">
             <a:avLst/>
@@ -14716,8 +14716,8 @@
         </p:nvSpPr>
         <p:spPr>
           <a:xfrm>
-            <a:off x="1460500" y="1981200"/>
-            <a:ext cx="8636000" cy="561340"/>
+            <a:off x="762000" y="1981200"/>
+            <a:ext cx="9334500" cy="561340"/>
           </a:xfrm>
           <a:prstGeom prst="rect">
             <a:avLst/>
@@ -14755,8 +14755,8 @@
         </p:nvSpPr>
         <p:spPr>
           <a:xfrm>
-            <a:off x="1460500" y="2682240"/>
-            <a:ext cx="8636000" cy="561340"/>
+            <a:off x="762000" y="2682240"/>
+            <a:ext cx="9334500" cy="561340"/>
           </a:xfrm>
           <a:prstGeom prst="rect">
             <a:avLst/>
@@ -15026,7 +15026,7 @@
         <p:spPr>
           <a:xfrm>
             <a:off x="762000" y="1270000"/>
-            <a:ext cx="9525000" cy="495300"/>
+            <a:ext cx="10668000" cy="495300"/>
           </a:xfrm>
           <a:prstGeom prst="rect">
             <a:avLst/>
@@ -15520,7 +15520,7 @@
         <p:spPr>
           <a:xfrm>
             <a:off x="762000" y="1079500"/>
-            <a:ext cx="10160000" cy="660400"/>
+            <a:ext cx="10160000" cy="1320800"/>
           </a:xfrm>
           <a:prstGeom prst="rect">
             <a:avLst/>
@@ -15559,7 +15559,7 @@
         <p:spPr>
           <a:xfrm>
             <a:off x="762000" y="1841500"/>
-            <a:ext cx="10160000" cy="254000"/>
+            <a:ext cx="10160000" cy="264160"/>
           </a:xfrm>
           <a:prstGeom prst="rect">
             <a:avLst/>
@@ -15637,7 +15637,7 @@
         <p:spPr>
           <a:xfrm>
             <a:off x="762000" y="2819400"/>
-            <a:ext cx="9525000" cy="177800"/>
+            <a:ext cx="9525000" cy="181610"/>
           </a:xfrm>
           <a:prstGeom prst="rect">
             <a:avLst/>
@@ -15676,7 +15676,7 @@
         <p:spPr>
           <a:xfrm>
             <a:off x="762000" y="3048000"/>
-            <a:ext cx="9525000" cy="177800"/>
+            <a:ext cx="9525000" cy="181610"/>
           </a:xfrm>
           <a:prstGeom prst="rect">
             <a:avLst/>
@@ -15715,7 +15715,7 @@
         <p:spPr>
           <a:xfrm>
             <a:off x="762000" y="3276600"/>
-            <a:ext cx="9525000" cy="177800"/>
+            <a:ext cx="9525000" cy="181610"/>
           </a:xfrm>
           <a:prstGeom prst="rect">
             <a:avLst/>
@@ -15754,7 +15754,7 @@
         <p:spPr>
           <a:xfrm>
             <a:off x="762000" y="3505200"/>
-            <a:ext cx="9525000" cy="177800"/>
+            <a:ext cx="9525000" cy="181610"/>
           </a:xfrm>
           <a:prstGeom prst="rect">
             <a:avLst/>
@@ -15793,7 +15793,7 @@
         <p:spPr>
           <a:xfrm>
             <a:off x="762000" y="3733800"/>
-            <a:ext cx="9525000" cy="177800"/>
+            <a:ext cx="9525000" cy="181610"/>
           </a:xfrm>
           <a:prstGeom prst="rect">
             <a:avLst/>
@@ -15832,7 +15832,7 @@
         <p:spPr>
           <a:xfrm>
             <a:off x="762000" y="3962400"/>
-            <a:ext cx="9525000" cy="177800"/>
+            <a:ext cx="9525000" cy="181610"/>
           </a:xfrm>
           <a:prstGeom prst="rect">
             <a:avLst/>
@@ -15871,7 +15871,7 @@
         <p:spPr>
           <a:xfrm>
             <a:off x="762000" y="4191000"/>
-            <a:ext cx="9525000" cy="177800"/>
+            <a:ext cx="9525000" cy="181610"/>
           </a:xfrm>
           <a:prstGeom prst="rect">
             <a:avLst/>
@@ -15910,7 +15910,7 @@
         <p:spPr>
           <a:xfrm>
             <a:off x="762000" y="4419600"/>
-            <a:ext cx="9525000" cy="177800"/>
+            <a:ext cx="9525000" cy="181610"/>
           </a:xfrm>
           <a:prstGeom prst="rect">
             <a:avLst/>
@@ -16172,7 +16172,7 @@
         <p:spPr>
           <a:xfrm>
             <a:off x="762000" y="1270000"/>
-            <a:ext cx="9525000" cy="495300"/>
+            <a:ext cx="10668000" cy="495300"/>
           </a:xfrm>
           <a:prstGeom prst="rect">
             <a:avLst/>
@@ -16626,8 +16626,8 @@
         </p:nvSpPr>
         <p:spPr>
           <a:xfrm>
-            <a:off x="0" y="2857500"/>
-            <a:ext cx="12192000" cy="952500"/>
+            <a:off x="0" y="2794000"/>
+            <a:ext cx="12192000" cy="990600"/>
           </a:xfrm>
           <a:prstGeom prst="rect">
             <a:avLst/>
@@ -16665,7 +16665,7 @@
         </p:nvSpPr>
         <p:spPr>
           <a:xfrm>
-            <a:off x="0" y="3810000"/>
+            <a:off x="0" y="3937000"/>
             <a:ext cx="12192000" cy="317500"/>
           </a:xfrm>
           <a:prstGeom prst="rect">
@@ -16704,7 +16704,7 @@
         </p:nvCxnSpPr>
         <p:spPr>
           <a:xfrm>
-            <a:off x="5588000" y="4445000"/>
+            <a:off x="5588000" y="4572000"/>
             <a:ext cx="1016000" cy="0"/>
           </a:xfrm>
           <a:prstGeom prst="line">
@@ -16739,7 +16739,7 @@
         </p:nvCxnSpPr>
         <p:spPr>
           <a:xfrm>
-            <a:off x="5588000" y="4521200"/>
+            <a:off x="5588000" y="4648200"/>
             <a:ext cx="1016000" cy="0"/>
           </a:xfrm>
           <a:prstGeom prst="line">
@@ -16889,7 +16889,7 @@
         <p:spPr>
           <a:xfrm>
             <a:off x="762000" y="1206500"/>
-            <a:ext cx="3937000" cy="1287780"/>
+            <a:ext cx="3810000" cy="1287780"/>
           </a:xfrm>
           <a:prstGeom prst="rect">
             <a:avLst/>
@@ -16928,7 +16928,7 @@
         <p:spPr>
           <a:xfrm>
             <a:off x="762000" y="2659380"/>
-            <a:ext cx="3937000" cy="693420"/>
+            <a:ext cx="3810000" cy="693420"/>
           </a:xfrm>
           <a:prstGeom prst="rect">
             <a:avLst/>
@@ -16967,7 +16967,7 @@
         <p:spPr>
           <a:xfrm>
             <a:off x="762000" y="3441700"/>
-            <a:ext cx="3937000" cy="693420"/>
+            <a:ext cx="3810000" cy="693420"/>
           </a:xfrm>
           <a:prstGeom prst="rect">
             <a:avLst/>
@@ -17006,7 +17006,7 @@
         <p:spPr>
           <a:xfrm>
             <a:off x="762000" y="4224020"/>
-            <a:ext cx="3937000" cy="462280"/>
+            <a:ext cx="3810000" cy="231140"/>
           </a:xfrm>
           <a:prstGeom prst="rect">
             <a:avLst/>
@@ -17052,8 +17052,8 @@
         </p:blipFill>
         <p:spPr>
           <a:xfrm>
-            <a:off x="5016500" y="1206500"/>
-            <a:ext cx="6413500" cy="2992966"/>
+            <a:off x="4889500" y="1794933"/>
+            <a:ext cx="6731000" cy="3141133"/>
           </a:xfrm>
           <a:prstGeom prst="rect">
             <a:avLst/>
@@ -17710,7 +17710,7 @@
         </p:nvSpPr>
         <p:spPr>
           <a:xfrm>
-            <a:off x="762000" y="1206500"/>
+            <a:off x="762000" y="1181100"/>
             <a:ext cx="10668000" cy="429260"/>
           </a:xfrm>
           <a:prstGeom prst="rect">
@@ -17749,27 +17749,27 @@
         </p:nvSpPr>
         <p:spPr>
           <a:xfrm>
-            <a:off x="762000" y="1800860"/>
-            <a:ext cx="4826000" cy="254000"/>
-          </a:xfrm>
-          <a:prstGeom prst="rect">
-            <a:avLst/>
-          </a:prstGeom>
-          <a:noFill/>
-        </p:spPr>
-        <p:txBody>
-          <a:bodyPr wrap="square" lIns="0" rIns="0" tIns="0" bIns="0" anchor="t">
-            <a:spAutoFit/>
-          </a:bodyPr>
-          <a:lstStyle/>
-          <a:p>
-            <a:pPr algn="l">
-              <a:lnSpc>
-                <a:spcPct val="115000"/>
-              </a:lnSpc>
-            </a:pPr>
-            <a:r>
-              <a:rPr sz="1500" b="0">
+            <a:off x="762000" y="1724660"/>
+            <a:ext cx="5207000" cy="231140"/>
+          </a:xfrm>
+          <a:prstGeom prst="rect">
+            <a:avLst/>
+          </a:prstGeom>
+          <a:noFill/>
+        </p:spPr>
+        <p:txBody>
+          <a:bodyPr wrap="square" lIns="0" rIns="0" tIns="0" bIns="0" anchor="t">
+            <a:spAutoFit/>
+          </a:bodyPr>
+          <a:lstStyle/>
+          <a:p>
+            <a:pPr algn="l">
+              <a:lnSpc>
+                <a:spcPct val="115000"/>
+              </a:lnSpc>
+            </a:pPr>
+            <a:r>
+              <a:rPr sz="1400" b="0">
                 <a:solidFill>
                   <a:srgbClr val="ECE7DD"/>
                 </a:solidFill>
@@ -17788,8 +17788,8 @@
         </p:nvSpPr>
         <p:spPr>
           <a:xfrm>
-            <a:off x="762000" y="2042160"/>
-            <a:ext cx="4826000" cy="198120"/>
+            <a:off x="762000" y="1953260"/>
+            <a:ext cx="5207000" cy="198120"/>
           </a:xfrm>
           <a:prstGeom prst="rect">
             <a:avLst/>
@@ -17827,27 +17827,27 @@
         </p:nvSpPr>
         <p:spPr>
           <a:xfrm>
-            <a:off x="762000" y="2341880"/>
-            <a:ext cx="4826000" cy="254000"/>
-          </a:xfrm>
-          <a:prstGeom prst="rect">
-            <a:avLst/>
-          </a:prstGeom>
-          <a:noFill/>
-        </p:spPr>
-        <p:txBody>
-          <a:bodyPr wrap="square" lIns="0" rIns="0" tIns="0" bIns="0" anchor="t">
-            <a:spAutoFit/>
-          </a:bodyPr>
-          <a:lstStyle/>
-          <a:p>
-            <a:pPr algn="l">
-              <a:lnSpc>
-                <a:spcPct val="115000"/>
-              </a:lnSpc>
-            </a:pPr>
-            <a:r>
-              <a:rPr sz="1500" b="0">
+            <a:off x="762000" y="2227580"/>
+            <a:ext cx="5207000" cy="231140"/>
+          </a:xfrm>
+          <a:prstGeom prst="rect">
+            <a:avLst/>
+          </a:prstGeom>
+          <a:noFill/>
+        </p:spPr>
+        <p:txBody>
+          <a:bodyPr wrap="square" lIns="0" rIns="0" tIns="0" bIns="0" anchor="t">
+            <a:spAutoFit/>
+          </a:bodyPr>
+          <a:lstStyle/>
+          <a:p>
+            <a:pPr algn="l">
+              <a:lnSpc>
+                <a:spcPct val="115000"/>
+              </a:lnSpc>
+            </a:pPr>
+            <a:r>
+              <a:rPr sz="1400" b="0">
                 <a:solidFill>
                   <a:srgbClr val="ECE7DD"/>
                 </a:solidFill>
@@ -17866,8 +17866,8 @@
         </p:nvSpPr>
         <p:spPr>
           <a:xfrm>
-            <a:off x="762000" y="2583180"/>
-            <a:ext cx="4826000" cy="396240"/>
+            <a:off x="762000" y="2456180"/>
+            <a:ext cx="5207000" cy="198120"/>
           </a:xfrm>
           <a:prstGeom prst="rect">
             <a:avLst/>
@@ -17905,27 +17905,27 @@
         </p:nvSpPr>
         <p:spPr>
           <a:xfrm>
-            <a:off x="762000" y="3081020"/>
-            <a:ext cx="4826000" cy="254000"/>
-          </a:xfrm>
-          <a:prstGeom prst="rect">
-            <a:avLst/>
-          </a:prstGeom>
-          <a:noFill/>
-        </p:spPr>
-        <p:txBody>
-          <a:bodyPr wrap="square" lIns="0" rIns="0" tIns="0" bIns="0" anchor="t">
-            <a:spAutoFit/>
-          </a:bodyPr>
-          <a:lstStyle/>
-          <a:p>
-            <a:pPr algn="l">
-              <a:lnSpc>
-                <a:spcPct val="115000"/>
-              </a:lnSpc>
-            </a:pPr>
-            <a:r>
-              <a:rPr sz="1500" b="0">
+            <a:off x="762000" y="2730500"/>
+            <a:ext cx="5207000" cy="231140"/>
+          </a:xfrm>
+          <a:prstGeom prst="rect">
+            <a:avLst/>
+          </a:prstGeom>
+          <a:noFill/>
+        </p:spPr>
+        <p:txBody>
+          <a:bodyPr wrap="square" lIns="0" rIns="0" tIns="0" bIns="0" anchor="t">
+            <a:spAutoFit/>
+          </a:bodyPr>
+          <a:lstStyle/>
+          <a:p>
+            <a:pPr algn="l">
+              <a:lnSpc>
+                <a:spcPct val="115000"/>
+              </a:lnSpc>
+            </a:pPr>
+            <a:r>
+              <a:rPr sz="1400" b="0">
                 <a:solidFill>
                   <a:srgbClr val="ECE7DD"/>
                 </a:solidFill>
@@ -17944,8 +17944,8 @@
         </p:nvSpPr>
         <p:spPr>
           <a:xfrm>
-            <a:off x="762000" y="3322320"/>
-            <a:ext cx="4826000" cy="396240"/>
+            <a:off x="762000" y="2959100"/>
+            <a:ext cx="5207000" cy="396240"/>
           </a:xfrm>
           <a:prstGeom prst="rect">
             <a:avLst/>
@@ -17983,27 +17983,27 @@
         </p:nvSpPr>
         <p:spPr>
           <a:xfrm>
-            <a:off x="762000" y="3820160"/>
-            <a:ext cx="4826000" cy="254000"/>
-          </a:xfrm>
-          <a:prstGeom prst="rect">
-            <a:avLst/>
-          </a:prstGeom>
-          <a:noFill/>
-        </p:spPr>
-        <p:txBody>
-          <a:bodyPr wrap="square" lIns="0" rIns="0" tIns="0" bIns="0" anchor="t">
-            <a:spAutoFit/>
-          </a:bodyPr>
-          <a:lstStyle/>
-          <a:p>
-            <a:pPr algn="l">
-              <a:lnSpc>
-                <a:spcPct val="115000"/>
-              </a:lnSpc>
-            </a:pPr>
-            <a:r>
-              <a:rPr sz="1500" b="0">
+            <a:off x="762000" y="3431540"/>
+            <a:ext cx="5207000" cy="231140"/>
+          </a:xfrm>
+          <a:prstGeom prst="rect">
+            <a:avLst/>
+          </a:prstGeom>
+          <a:noFill/>
+        </p:spPr>
+        <p:txBody>
+          <a:bodyPr wrap="square" lIns="0" rIns="0" tIns="0" bIns="0" anchor="t">
+            <a:spAutoFit/>
+          </a:bodyPr>
+          <a:lstStyle/>
+          <a:p>
+            <a:pPr algn="l">
+              <a:lnSpc>
+                <a:spcPct val="115000"/>
+              </a:lnSpc>
+            </a:pPr>
+            <a:r>
+              <a:rPr sz="1400" b="0">
                 <a:solidFill>
                   <a:srgbClr val="ECE7DD"/>
                 </a:solidFill>
@@ -18022,8 +18022,8 @@
         </p:nvSpPr>
         <p:spPr>
           <a:xfrm>
-            <a:off x="762000" y="4061460"/>
-            <a:ext cx="4826000" cy="396240"/>
+            <a:off x="762000" y="3660140"/>
+            <a:ext cx="5207000" cy="198120"/>
           </a:xfrm>
           <a:prstGeom prst="rect">
             <a:avLst/>
@@ -18061,27 +18061,27 @@
         </p:nvSpPr>
         <p:spPr>
           <a:xfrm>
-            <a:off x="762000" y="4559300"/>
-            <a:ext cx="4826000" cy="254000"/>
-          </a:xfrm>
-          <a:prstGeom prst="rect">
-            <a:avLst/>
-          </a:prstGeom>
-          <a:noFill/>
-        </p:spPr>
-        <p:txBody>
-          <a:bodyPr wrap="square" lIns="0" rIns="0" tIns="0" bIns="0" anchor="t">
-            <a:spAutoFit/>
-          </a:bodyPr>
-          <a:lstStyle/>
-          <a:p>
-            <a:pPr algn="l">
-              <a:lnSpc>
-                <a:spcPct val="115000"/>
-              </a:lnSpc>
-            </a:pPr>
-            <a:r>
-              <a:rPr sz="1500" b="0">
+            <a:off x="762000" y="3934460"/>
+            <a:ext cx="5207000" cy="231140"/>
+          </a:xfrm>
+          <a:prstGeom prst="rect">
+            <a:avLst/>
+          </a:prstGeom>
+          <a:noFill/>
+        </p:spPr>
+        <p:txBody>
+          <a:bodyPr wrap="square" lIns="0" rIns="0" tIns="0" bIns="0" anchor="t">
+            <a:spAutoFit/>
+          </a:bodyPr>
+          <a:lstStyle/>
+          <a:p>
+            <a:pPr algn="l">
+              <a:lnSpc>
+                <a:spcPct val="115000"/>
+              </a:lnSpc>
+            </a:pPr>
+            <a:r>
+              <a:rPr sz="1400" b="0">
                 <a:solidFill>
                   <a:srgbClr val="ECE7DD"/>
                 </a:solidFill>
@@ -18100,8 +18100,8 @@
         </p:nvSpPr>
         <p:spPr>
           <a:xfrm>
-            <a:off x="762000" y="4800600"/>
-            <a:ext cx="4826000" cy="198120"/>
+            <a:off x="762000" y="4163060"/>
+            <a:ext cx="5207000" cy="198120"/>
           </a:xfrm>
           <a:prstGeom prst="rect">
             <a:avLst/>
@@ -18139,27 +18139,27 @@
         </p:nvSpPr>
         <p:spPr>
           <a:xfrm>
-            <a:off x="762000" y="5100320"/>
-            <a:ext cx="4826000" cy="254000"/>
-          </a:xfrm>
-          <a:prstGeom prst="rect">
-            <a:avLst/>
-          </a:prstGeom>
-          <a:noFill/>
-        </p:spPr>
-        <p:txBody>
-          <a:bodyPr wrap="square" lIns="0" rIns="0" tIns="0" bIns="0" anchor="t">
-            <a:spAutoFit/>
-          </a:bodyPr>
-          <a:lstStyle/>
-          <a:p>
-            <a:pPr algn="l">
-              <a:lnSpc>
-                <a:spcPct val="115000"/>
-              </a:lnSpc>
-            </a:pPr>
-            <a:r>
-              <a:rPr sz="1500" b="0">
+            <a:off x="762000" y="4437380"/>
+            <a:ext cx="5207000" cy="231140"/>
+          </a:xfrm>
+          <a:prstGeom prst="rect">
+            <a:avLst/>
+          </a:prstGeom>
+          <a:noFill/>
+        </p:spPr>
+        <p:txBody>
+          <a:bodyPr wrap="square" lIns="0" rIns="0" tIns="0" bIns="0" anchor="t">
+            <a:spAutoFit/>
+          </a:bodyPr>
+          <a:lstStyle/>
+          <a:p>
+            <a:pPr algn="l">
+              <a:lnSpc>
+                <a:spcPct val="115000"/>
+              </a:lnSpc>
+            </a:pPr>
+            <a:r>
+              <a:rPr sz="1400" b="0">
                 <a:solidFill>
                   <a:srgbClr val="ECE7DD"/>
                 </a:solidFill>
@@ -18178,8 +18178,8 @@
         </p:nvSpPr>
         <p:spPr>
           <a:xfrm>
-            <a:off x="762000" y="5341620"/>
-            <a:ext cx="4826000" cy="396240"/>
+            <a:off x="762000" y="4665980"/>
+            <a:ext cx="5207000" cy="396240"/>
           </a:xfrm>
           <a:prstGeom prst="rect">
             <a:avLst/>
@@ -18225,8 +18225,8 @@
         </p:blipFill>
         <p:spPr>
           <a:xfrm>
-            <a:off x="6096000" y="1905000"/>
-            <a:ext cx="5334000" cy="2667000"/>
+            <a:off x="6350000" y="1905000"/>
+            <a:ext cx="5080000" cy="2540000"/>
           </a:xfrm>
           <a:prstGeom prst="rect">
             <a:avLst/>
@@ -18512,7 +18512,7 @@
         <p:spPr>
           <a:xfrm>
             <a:off x="762000" y="1206500"/>
-            <a:ext cx="3937000" cy="858520"/>
+            <a:ext cx="3810000" cy="858520"/>
           </a:xfrm>
           <a:prstGeom prst="rect">
             <a:avLst/>
@@ -18551,7 +18551,7 @@
         <p:spPr>
           <a:xfrm>
             <a:off x="762000" y="2230120"/>
-            <a:ext cx="3937000" cy="462280"/>
+            <a:ext cx="3810000" cy="462280"/>
           </a:xfrm>
           <a:prstGeom prst="rect">
             <a:avLst/>
@@ -18590,7 +18590,7 @@
         <p:spPr>
           <a:xfrm>
             <a:off x="762000" y="2781300"/>
-            <a:ext cx="3937000" cy="462280"/>
+            <a:ext cx="3810000" cy="462280"/>
           </a:xfrm>
           <a:prstGeom prst="rect">
             <a:avLst/>
@@ -18629,7 +18629,7 @@
         <p:spPr>
           <a:xfrm>
             <a:off x="762000" y="3332480"/>
-            <a:ext cx="3937000" cy="462280"/>
+            <a:ext cx="3810000" cy="462280"/>
           </a:xfrm>
           <a:prstGeom prst="rect">
             <a:avLst/>
@@ -18668,7 +18668,7 @@
         <p:spPr>
           <a:xfrm>
             <a:off x="762000" y="3883660"/>
-            <a:ext cx="3937000" cy="462280"/>
+            <a:ext cx="3810000" cy="462280"/>
           </a:xfrm>
           <a:prstGeom prst="rect">
             <a:avLst/>
@@ -18707,7 +18707,7 @@
         <p:spPr>
           <a:xfrm>
             <a:off x="762000" y="4434840"/>
-            <a:ext cx="3937000" cy="462280"/>
+            <a:ext cx="3810000" cy="462280"/>
           </a:xfrm>
           <a:prstGeom prst="rect">
             <a:avLst/>
@@ -18746,7 +18746,7 @@
         <p:spPr>
           <a:xfrm>
             <a:off x="762000" y="4986020"/>
-            <a:ext cx="3937000" cy="462280"/>
+            <a:ext cx="3810000" cy="462280"/>
           </a:xfrm>
           <a:prstGeom prst="rect">
             <a:avLst/>
@@ -18792,8 +18792,8 @@
         </p:blipFill>
         <p:spPr>
           <a:xfrm>
-            <a:off x="5016500" y="1206500"/>
-            <a:ext cx="6413500" cy="3078480"/>
+            <a:off x="4889500" y="1750060"/>
+            <a:ext cx="6731000" cy="3230880"/>
           </a:xfrm>
           <a:prstGeom prst="rect">
             <a:avLst/>

</xml_diff>

<commit_message>
fix(deck): final review fixes
- slide 14: pillar leaders on the 17 unbranded prompts, row n shown, retitled
- slide 20: title states site and page overlap
- slide 19: light the types each engine's claim is about
- slide 24: lead with Bank Mandiri, alias caveat on the slide
- slide 12: small VIS gaps read as close
- measure.LINE 1.4 (rendered pitch 1.379 em), cold open gap 24 px
- Zaipad and Akulaku at page level, looked up by domain; slide 28 says sites
- slide 17 hedged, slide 21 lights Gemini-only sites, every chart footnote states n

Co-Authored-By: Claude Opus 5.5 <noreply@anthropic.com>
Claude-Session: https://claude.ai/code/session_016QENrZoUiH2GSA5C6QaHnv
</commit_message>
<xml_diff>
--- a/deck/out/favoured-banks.pptx
+++ b/deck/out/favoured-banks.pptx
@@ -743,7 +743,7 @@
           <a:lstStyle/>
           <a:p>
             <a:r>
-              <a:t>Outlined cells are the leader in each row. BCA's digital lead comes largely through its apps.</a:t>
+              <a:t>The three comparison prompts name banks, which puts those banks in the answer, so they are left out here. Outlined cells lead their row, ties together. Every lead is a tie or one answer, so read the rows as close.</a:t>
             </a:r>
           </a:p>
         </p:txBody>
@@ -5306,7 +5306,7 @@
         <p:spPr>
           <a:xfrm>
             <a:off x="762000" y="1905000"/>
-            <a:ext cx="10160000" cy="190500"/>
+            <a:ext cx="10160000" cy="195579"/>
           </a:xfrm>
           <a:prstGeom prst="rect">
             <a:avLst/>
@@ -5345,7 +5345,7 @@
         <p:spPr>
           <a:xfrm>
             <a:off x="762000" y="2159000"/>
-            <a:ext cx="10668000" cy="1333500"/>
+            <a:ext cx="10668000" cy="1422400"/>
           </a:xfrm>
           <a:prstGeom prst="rect">
             <a:avLst/>
@@ -5384,7 +5384,7 @@
         <p:spPr>
           <a:xfrm>
             <a:off x="762000" y="3556000"/>
-            <a:ext cx="7302500" cy="660400"/>
+            <a:ext cx="7302500" cy="711200"/>
           </a:xfrm>
           <a:prstGeom prst="rect">
             <a:avLst/>
@@ -5597,7 +5597,7 @@
         <p:spPr>
           <a:xfrm>
             <a:off x="0" y="2794000"/>
-            <a:ext cx="12192000" cy="990600"/>
+            <a:ext cx="12192000" cy="1066800"/>
           </a:xfrm>
           <a:prstGeom prst="rect">
             <a:avLst/>
@@ -5636,7 +5636,7 @@
         <p:spPr>
           <a:xfrm>
             <a:off x="0" y="3937000"/>
-            <a:ext cx="12192000" cy="317500"/>
+            <a:ext cx="12192000" cy="320040"/>
           </a:xfrm>
           <a:prstGeom prst="rect">
             <a:avLst/>
@@ -5859,7 +5859,7 @@
         <p:spPr>
           <a:xfrm>
             <a:off x="762000" y="1206500"/>
-            <a:ext cx="3810000" cy="1717040"/>
+            <a:ext cx="3810000" cy="1849120"/>
           </a:xfrm>
           <a:prstGeom prst="rect">
             <a:avLst/>
@@ -5897,8 +5897,8 @@
         </p:nvSpPr>
         <p:spPr>
           <a:xfrm>
-            <a:off x="762000" y="3088640"/>
-            <a:ext cx="3810000" cy="462280"/>
+            <a:off x="762000" y="3220720"/>
+            <a:ext cx="3810000" cy="497839"/>
           </a:xfrm>
           <a:prstGeom prst="rect">
             <a:avLst/>
@@ -6103,7 +6103,7 @@
                 </a:solidFill>
                 <a:latin typeface="IBM Plex Mono"/>
               </a:rPr>
-              <a:t>source: data/processed/brand_engine.csv  ·  top 10 banks</a:t>
+              <a:t>source: data/processed/brand_engine.csv  ·  top 10 banks  ·  n = 20 answers per engine</a:t>
             </a:r>
           </a:p>
         </p:txBody>
@@ -6231,7 +6231,7 @@
         <p:spPr>
           <a:xfrm>
             <a:off x="762000" y="1206500"/>
-            <a:ext cx="3810000" cy="858520"/>
+            <a:ext cx="3810000" cy="1386839"/>
           </a:xfrm>
           <a:prstGeom prst="rect">
             <a:avLst/>
@@ -6256,7 +6256,7 @@
                 </a:solidFill>
                 <a:latin typeface="Work Sans"/>
               </a:rPr>
-              <a:t>BCA has the highest visibility score</a:t>
+              <a:t>BCA scores highest, with Bank Jago and BRI close behind</a:t>
             </a:r>
           </a:p>
         </p:txBody>
@@ -6269,8 +6269,8 @@
         </p:nvSpPr>
         <p:spPr>
           <a:xfrm>
-            <a:off x="762000" y="2230120"/>
-            <a:ext cx="3810000" cy="462280"/>
+            <a:off x="762000" y="2758440"/>
+            <a:ext cx="3810000" cy="497839"/>
           </a:xfrm>
           <a:prstGeom prst="rect">
             <a:avLst/>
@@ -6308,8 +6308,8 @@
         </p:nvSpPr>
         <p:spPr>
           <a:xfrm>
-            <a:off x="762000" y="2781300"/>
-            <a:ext cx="3810000" cy="462280"/>
+            <a:off x="762000" y="3345179"/>
+            <a:ext cx="3810000" cy="497839"/>
           </a:xfrm>
           <a:prstGeom prst="rect">
             <a:avLst/>
@@ -6514,7 +6514,7 @@
                 </a:solidFill>
                 <a:latin typeface="IBM Plex Mono"/>
               </a:rPr>
-              <a:t>source: data/processed/vis.csv</a:t>
+              <a:t>source: data/processed/vis.csv  ·  n = 40 answers</a:t>
             </a:r>
           </a:p>
         </p:txBody>
@@ -6642,7 +6642,7 @@
         <p:spPr>
           <a:xfrm>
             <a:off x="762000" y="1181100"/>
-            <a:ext cx="10668000" cy="429260"/>
+            <a:ext cx="10668000" cy="462280"/>
           </a:xfrm>
           <a:prstGeom prst="rect">
             <a:avLst/>
@@ -6680,8 +6680,8 @@
         </p:nvSpPr>
         <p:spPr>
           <a:xfrm>
-            <a:off x="762000" y="1699260"/>
-            <a:ext cx="8572500" cy="462280"/>
+            <a:off x="762000" y="1732280"/>
+            <a:ext cx="8572500" cy="497839"/>
           </a:xfrm>
           <a:prstGeom prst="rect">
             <a:avLst/>
@@ -6727,7 +6727,7 @@
         </p:blipFill>
         <p:spPr>
           <a:xfrm>
-            <a:off x="762000" y="2275840"/>
+            <a:off x="762000" y="2344420"/>
             <a:ext cx="10668000" cy="2730500"/>
           </a:xfrm>
           <a:prstGeom prst="rect">
@@ -6886,7 +6886,7 @@
                 </a:solidFill>
                 <a:latin typeface="IBM Plex Mono"/>
               </a:rPr>
-              <a:t>source: data/processed/brand_engine.csv</a:t>
+              <a:t>source: data/processed/brand_engine.csv  ·  n = 20 answers per engine</a:t>
             </a:r>
           </a:p>
         </p:txBody>
@@ -7014,7 +7014,7 @@
         <p:spPr>
           <a:xfrm>
             <a:off x="762000" y="1181100"/>
-            <a:ext cx="10668000" cy="429260"/>
+            <a:ext cx="10668000" cy="924560"/>
           </a:xfrm>
           <a:prstGeom prst="rect">
             <a:avLst/>
@@ -7039,7 +7039,7 @@
                 </a:solidFill>
                 <a:latin typeface="Work Sans"/>
               </a:rPr>
-              <a:t>Each customer need has its own leading bank</a:t>
+              <a:t>No bank leads every customer need, and no lead is more than one answer</a:t>
             </a:r>
           </a:p>
         </p:txBody>
@@ -7052,8 +7052,8 @@
         </p:nvSpPr>
         <p:spPr>
           <a:xfrm>
-            <a:off x="762000" y="1699260"/>
-            <a:ext cx="8572500" cy="462280"/>
+            <a:off x="762000" y="2194560"/>
+            <a:ext cx="8572500" cy="746760"/>
           </a:xfrm>
           <a:prstGeom prst="rect">
             <a:avLst/>
@@ -7078,7 +7078,7 @@
                 </a:solidFill>
                 <a:latin typeface="Work Sans"/>
               </a:rPr>
-              <a:t>Fees and rates: Bank Jago and SeaBank (80%). Digital experience: BCA (88%). Safety: Bank Jago (63%). Service: BRI (63%). Trust: BCA (50%).</a:t>
+              <a:t>Counted on the 17 prompts that name no bank. Fees and rates: Bank Jago, Krom Bank and SeaBank, 6 of 8. Digital experience: Bank Jago and SeaBank, 6 of 6. Safety: Bank Jago, 5 of 8. Service: BCA, 4 of 6. Trust: BCA, 3 of 6.</a:t>
             </a:r>
           </a:p>
         </p:txBody>
@@ -7099,8 +7099,8 @@
         </p:blipFill>
         <p:spPr>
           <a:xfrm>
-            <a:off x="1108710" y="2275840"/>
-            <a:ext cx="9974579" cy="3324859"/>
+            <a:off x="2278380" y="3055620"/>
+            <a:ext cx="7635239" cy="2545079"/>
           </a:xfrm>
           <a:prstGeom prst="rect">
             <a:avLst/>
@@ -7258,7 +7258,7 @@
                 </a:solidFill>
                 <a:latin typeface="IBM Plex Mono"/>
               </a:rPr>
-              <a:t>source: data/processed/brand_pillar.csv  ·  share of answers in each pillar that name the bank</a:t>
+              <a:t>source: data/interim/answers.csv, mentions.csv  ·  share of a need's answers that name the bank  ·  n = 34 answers</a:t>
             </a:r>
           </a:p>
         </p:txBody>
@@ -7386,7 +7386,7 @@
         <p:spPr>
           <a:xfrm>
             <a:off x="762000" y="1206500"/>
-            <a:ext cx="3810000" cy="1287780"/>
+            <a:ext cx="3810000" cy="1386839"/>
           </a:xfrm>
           <a:prstGeom prst="rect">
             <a:avLst/>
@@ -7424,8 +7424,8 @@
         </p:nvSpPr>
         <p:spPr>
           <a:xfrm>
-            <a:off x="762000" y="2659380"/>
-            <a:ext cx="3810000" cy="462280"/>
+            <a:off x="762000" y="2758440"/>
+            <a:ext cx="3810000" cy="497839"/>
           </a:xfrm>
           <a:prstGeom prst="rect">
             <a:avLst/>
@@ -7463,8 +7463,8 @@
         </p:nvSpPr>
         <p:spPr>
           <a:xfrm>
-            <a:off x="762000" y="3210560"/>
-            <a:ext cx="3810000" cy="924560"/>
+            <a:off x="762000" y="3345179"/>
+            <a:ext cx="3810000" cy="995679"/>
           </a:xfrm>
           <a:prstGeom prst="rect">
             <a:avLst/>
@@ -7669,7 +7669,7 @@
                 </a:solidFill>
                 <a:latin typeface="IBM Plex Mono"/>
               </a:rPr>
-              <a:t>source: data/processed/brand_engine.csv  ·  banks named in at least 3 answers</a:t>
+              <a:t>source: data/processed/brand_engine.csv  ·  banks named in at least 3 answers  ·  n = 40 answers</a:t>
             </a:r>
           </a:p>
         </p:txBody>
@@ -7797,7 +7797,7 @@
         <p:spPr>
           <a:xfrm>
             <a:off x="762000" y="1181100"/>
-            <a:ext cx="10668000" cy="429260"/>
+            <a:ext cx="10668000" cy="462280"/>
           </a:xfrm>
           <a:prstGeom prst="rect">
             <a:avLst/>
@@ -7835,8 +7835,8 @@
         </p:nvSpPr>
         <p:spPr>
           <a:xfrm>
-            <a:off x="762000" y="1699260"/>
-            <a:ext cx="8572500" cy="462280"/>
+            <a:off x="762000" y="1732280"/>
+            <a:ext cx="8572500" cy="497839"/>
           </a:xfrm>
           <a:prstGeom prst="rect">
             <a:avLst/>
@@ -7882,7 +7882,7 @@
         </p:blipFill>
         <p:spPr>
           <a:xfrm>
-            <a:off x="762000" y="2275840"/>
+            <a:off x="762000" y="2344420"/>
             <a:ext cx="10668000" cy="2413000"/>
           </a:xfrm>
           <a:prstGeom prst="rect">
@@ -8041,7 +8041,7 @@
                 </a:solidFill>
                 <a:latin typeface="IBM Plex Mono"/>
               </a:rPr>
-              <a:t>source: data/labels/sentiment.csv  ·  labelled by Claude, spot-checked by RG</a:t>
+              <a:t>source: data/labels/sentiment.csv  ·  labelled by Claude, spot-checked by RG  ·  n = 137 pairs</a:t>
             </a:r>
           </a:p>
         </p:txBody>
@@ -8169,7 +8169,7 @@
         <p:spPr>
           <a:xfrm>
             <a:off x="762000" y="1206500"/>
-            <a:ext cx="3810000" cy="858520"/>
+            <a:ext cx="3810000" cy="924560"/>
           </a:xfrm>
           <a:prstGeom prst="rect">
             <a:avLst/>
@@ -8207,8 +8207,8 @@
         </p:nvSpPr>
         <p:spPr>
           <a:xfrm>
-            <a:off x="762000" y="2230120"/>
-            <a:ext cx="3810000" cy="462280"/>
+            <a:off x="762000" y="2296160"/>
+            <a:ext cx="3810000" cy="497839"/>
           </a:xfrm>
           <a:prstGeom prst="rect">
             <a:avLst/>
@@ -8246,8 +8246,8 @@
         </p:nvSpPr>
         <p:spPr>
           <a:xfrm>
-            <a:off x="762000" y="2781300"/>
-            <a:ext cx="3810000" cy="693420"/>
+            <a:off x="762000" y="2882900"/>
+            <a:ext cx="3810000" cy="746760"/>
           </a:xfrm>
           <a:prstGeom prst="rect">
             <a:avLst/>
@@ -8272,7 +8272,7 @@
                 </a:solidFill>
                 <a:latin typeface="Work Sans"/>
               </a:rPr>
-              <a:t>Only 1 of 6 how-to answers did. Explainers on deposit insurance, scams and complaints are a gap for banks.</a:t>
+              <a:t>Only 1 of 6 how-to answers did. Explainers on deposit insurance, scams and complaints look like a gap for banks.</a:t>
             </a:r>
           </a:p>
         </p:txBody>
@@ -8452,7 +8452,7 @@
                 </a:solidFill>
                 <a:latin typeface="IBM Plex Mono"/>
               </a:rPr>
-              <a:t>source: data/processed/no_brand_rate.csv</a:t>
+              <a:t>source: data/processed/no_brand_rate.csv  ·  n = 40 answers</a:t>
             </a:r>
           </a:p>
         </p:txBody>
@@ -8531,7 +8531,7 @@
         <p:spPr>
           <a:xfrm>
             <a:off x="0" y="2794000"/>
-            <a:ext cx="12192000" cy="990600"/>
+            <a:ext cx="12192000" cy="1066800"/>
           </a:xfrm>
           <a:prstGeom prst="rect">
             <a:avLst/>
@@ -8570,7 +8570,7 @@
         <p:spPr>
           <a:xfrm>
             <a:off x="0" y="3937000"/>
-            <a:ext cx="12192000" cy="317500"/>
+            <a:ext cx="12192000" cy="320040"/>
           </a:xfrm>
           <a:prstGeom prst="rect">
             <a:avLst/>
@@ -8793,7 +8793,7 @@
         <p:spPr>
           <a:xfrm>
             <a:off x="762000" y="1181100"/>
-            <a:ext cx="10668000" cy="858520"/>
+            <a:ext cx="10668000" cy="924560"/>
           </a:xfrm>
           <a:prstGeom prst="rect">
             <a:avLst/>
@@ -8831,8 +8831,8 @@
         </p:nvSpPr>
         <p:spPr>
           <a:xfrm>
-            <a:off x="762000" y="2128520"/>
-            <a:ext cx="8572500" cy="462280"/>
+            <a:off x="762000" y="2194560"/>
+            <a:ext cx="8572500" cy="497839"/>
           </a:xfrm>
           <a:prstGeom prst="rect">
             <a:avLst/>
@@ -8878,8 +8878,8 @@
         </p:blipFill>
         <p:spPr>
           <a:xfrm>
-            <a:off x="808382" y="2705100"/>
-            <a:ext cx="10575234" cy="2895599"/>
+            <a:off x="993913" y="2806700"/>
+            <a:ext cx="10204173" cy="2794000"/>
           </a:xfrm>
           <a:prstGeom prst="rect">
             <a:avLst/>
@@ -9037,7 +9037,7 @@
                 </a:solidFill>
                 <a:latin typeface="IBM Plex Mono"/>
               </a:rPr>
-              <a:t>source: data/processed/domain_type_mix.csv  ·  each share rounded on its own, so sums can differ by 1 point</a:t>
+              <a:t>source: data/processed/domain_type_mix.csv  ·  shares rounded on their own, sums can differ by 1 point  ·  n = 199 and 200 citations</a:t>
             </a:r>
           </a:p>
         </p:txBody>
@@ -9165,7 +9165,7 @@
         <p:spPr>
           <a:xfrm>
             <a:off x="762000" y="1206500"/>
-            <a:ext cx="10668000" cy="429260"/>
+            <a:ext cx="10668000" cy="462280"/>
           </a:xfrm>
           <a:prstGeom prst="rect">
             <a:avLst/>
@@ -9203,8 +9203,8 @@
         </p:nvSpPr>
         <p:spPr>
           <a:xfrm>
-            <a:off x="762000" y="1826260"/>
-            <a:ext cx="9525000" cy="1089660"/>
+            <a:off x="762000" y="1859280"/>
+            <a:ext cx="9525000" cy="1173480"/>
           </a:xfrm>
           <a:prstGeom prst="rect">
             <a:avLst/>
@@ -9242,8 +9242,8 @@
         </p:nvSpPr>
         <p:spPr>
           <a:xfrm>
-            <a:off x="762000" y="2979420"/>
-            <a:ext cx="9525000" cy="462280"/>
+            <a:off x="762000" y="3185160"/>
+            <a:ext cx="9525000" cy="497839"/>
           </a:xfrm>
           <a:prstGeom prst="rect">
             <a:avLst/>
@@ -9281,7 +9281,7 @@
         </p:nvSpPr>
         <p:spPr>
           <a:xfrm>
-            <a:off x="762000" y="3873500"/>
+            <a:off x="762000" y="4114800"/>
             <a:ext cx="88900" cy="88900"/>
           </a:xfrm>
           <a:prstGeom prst="rect">
@@ -9325,8 +9325,8 @@
         </p:nvSpPr>
         <p:spPr>
           <a:xfrm>
-            <a:off x="952500" y="3822700"/>
-            <a:ext cx="3810000" cy="190500"/>
+            <a:off x="952500" y="4064000"/>
+            <a:ext cx="3810000" cy="195579"/>
           </a:xfrm>
           <a:prstGeom prst="rect">
             <a:avLst/>
@@ -9364,8 +9364,8 @@
         </p:nvSpPr>
         <p:spPr>
           <a:xfrm>
-            <a:off x="762000" y="4140200"/>
-            <a:ext cx="4318000" cy="1188720"/>
+            <a:off x="762000" y="4381500"/>
+            <a:ext cx="4318000" cy="1280159"/>
           </a:xfrm>
           <a:prstGeom prst="rect">
             <a:avLst/>
@@ -9435,7 +9435,7 @@
         </p:nvSpPr>
         <p:spPr>
           <a:xfrm>
-            <a:off x="5588000" y="3873500"/>
+            <a:off x="5588000" y="4114800"/>
             <a:ext cx="88900" cy="88900"/>
           </a:xfrm>
           <a:prstGeom prst="rect">
@@ -9479,8 +9479,8 @@
         </p:nvSpPr>
         <p:spPr>
           <a:xfrm>
-            <a:off x="5778500" y="3822700"/>
-            <a:ext cx="3810000" cy="190500"/>
+            <a:off x="5778500" y="4064000"/>
+            <a:ext cx="3810000" cy="195579"/>
           </a:xfrm>
           <a:prstGeom prst="rect">
             <a:avLst/>
@@ -9518,8 +9518,8 @@
         </p:nvSpPr>
         <p:spPr>
           <a:xfrm>
-            <a:off x="5588000" y="4140200"/>
-            <a:ext cx="4318000" cy="1188720"/>
+            <a:off x="5588000" y="4381500"/>
+            <a:ext cx="4318000" cy="1280159"/>
           </a:xfrm>
           <a:prstGeom prst="rect">
             <a:avLst/>
@@ -9860,7 +9860,7 @@
         <p:spPr>
           <a:xfrm>
             <a:off x="762000" y="1206500"/>
-            <a:ext cx="3810000" cy="858520"/>
+            <a:ext cx="3810000" cy="1849120"/>
           </a:xfrm>
           <a:prstGeom prst="rect">
             <a:avLst/>
@@ -9885,7 +9885,7 @@
                 </a:solidFill>
                 <a:latin typeface="Work Sans"/>
               </a:rPr>
-              <a:t>The two engines barely share a source</a:t>
+              <a:t>The engines share sites more than pages: 21 of 97 sites, 11 of 243 pages</a:t>
             </a:r>
           </a:p>
         </p:txBody>
@@ -9898,8 +9898,8 @@
         </p:nvSpPr>
         <p:spPr>
           <a:xfrm>
-            <a:off x="762000" y="2230120"/>
-            <a:ext cx="3810000" cy="693420"/>
+            <a:off x="762000" y="3220720"/>
+            <a:ext cx="3810000" cy="995679"/>
           </a:xfrm>
           <a:prstGeom prst="rect">
             <a:avLst/>
@@ -9924,7 +9924,7 @@
                 </a:solidFill>
                 <a:latin typeface="Work Sans"/>
               </a:rPr>
-              <a:t>21 of 97 sites and 11 of 243 pages are cited by both. That is a Jaccard overlap of 0.22 for sites and 0.05 for pages.</a:t>
+              <a:t>21 of ChatGPT's 46 sites are also cited by Gemini, but rarely the same page. The Jaccard overlap is 0.22 for sites and 0.05 for pages.</a:t>
             </a:r>
           </a:p>
         </p:txBody>
@@ -9937,8 +9937,8 @@
         </p:nvSpPr>
         <p:spPr>
           <a:xfrm>
-            <a:off x="762000" y="3012440"/>
-            <a:ext cx="3810000" cy="924560"/>
+            <a:off x="762000" y="4305300"/>
+            <a:ext cx="3810000" cy="995679"/>
           </a:xfrm>
           <a:prstGeom prst="rect">
             <a:avLst/>
@@ -10143,7 +10143,7 @@
                 </a:solidFill>
                 <a:latin typeface="IBM Plex Mono"/>
               </a:rPr>
-              <a:t>source: data/interim/citations.csv  ·  Writesonic, AI citation source overlap study</a:t>
+              <a:t>source: data/interim/citations.csv  ·  Writesonic, AI citation source overlap study  ·  n = 97 sites, 243 pages</a:t>
             </a:r>
           </a:p>
         </p:txBody>
@@ -10271,7 +10271,7 @@
         <p:spPr>
           <a:xfrm>
             <a:off x="762000" y="1181100"/>
-            <a:ext cx="10668000" cy="429260"/>
+            <a:ext cx="10668000" cy="462280"/>
           </a:xfrm>
           <a:prstGeom prst="rect">
             <a:avLst/>
@@ -10309,8 +10309,8 @@
         </p:nvSpPr>
         <p:spPr>
           <a:xfrm>
-            <a:off x="762000" y="1699260"/>
-            <a:ext cx="8572500" cy="231140"/>
+            <a:off x="762000" y="1732280"/>
+            <a:ext cx="8572500" cy="248919"/>
           </a:xfrm>
           <a:prstGeom prst="rect">
             <a:avLst/>
@@ -10356,8 +10356,8 @@
         </p:blipFill>
         <p:spPr>
           <a:xfrm>
-            <a:off x="1570181" y="2044700"/>
-            <a:ext cx="9051636" cy="3556000"/>
+            <a:off x="1634836" y="2095500"/>
+            <a:ext cx="8922327" cy="3505200"/>
           </a:xfrm>
           <a:prstGeom prst="rect">
             <a:avLst/>
@@ -10515,7 +10515,7 @@
                 </a:solidFill>
                 <a:latin typeface="IBM Plex Mono"/>
               </a:rPr>
-              <a:t>source: data/processed/domains.csv  ·  top sites by citations</a:t>
+              <a:t>source: data/processed/domains.csv  ·  top sites by citations  ·  n = 399 citations</a:t>
             </a:r>
           </a:p>
         </p:txBody>
@@ -10643,7 +10643,7 @@
         <p:spPr>
           <a:xfrm>
             <a:off x="762000" y="1181100"/>
-            <a:ext cx="10668000" cy="429260"/>
+            <a:ext cx="10668000" cy="462280"/>
           </a:xfrm>
           <a:prstGeom prst="rect">
             <a:avLst/>
@@ -10681,8 +10681,8 @@
         </p:nvSpPr>
         <p:spPr>
           <a:xfrm>
-            <a:off x="762000" y="1699260"/>
-            <a:ext cx="8572500" cy="462280"/>
+            <a:off x="762000" y="1732280"/>
+            <a:ext cx="8572500" cy="497839"/>
           </a:xfrm>
           <a:prstGeom prst="rect">
             <a:avLst/>
@@ -10720,8 +10720,8 @@
         </p:nvSpPr>
         <p:spPr>
           <a:xfrm>
-            <a:off x="762000" y="2212340"/>
-            <a:ext cx="8572500" cy="462280"/>
+            <a:off x="762000" y="2280920"/>
+            <a:ext cx="8572500" cy="497839"/>
           </a:xfrm>
           <a:prstGeom prst="rect">
             <a:avLst/>
@@ -10767,8 +10767,8 @@
         </p:blipFill>
         <p:spPr>
           <a:xfrm>
-            <a:off x="2159508" y="2788920"/>
-            <a:ext cx="7872983" cy="2811779"/>
+            <a:off x="2305304" y="2893060"/>
+            <a:ext cx="7581392" cy="2707640"/>
           </a:xfrm>
           <a:prstGeom prst="rect">
             <a:avLst/>
@@ -10926,7 +10926,7 @@
                 </a:solidFill>
                 <a:latin typeface="IBM Plex Mono"/>
               </a:rPr>
-              <a:t>source: data/processed/pages_top.csv  ·  most cited pages</a:t>
+              <a:t>source: data/processed/pages_top.csv  ·  most cited pages  ·  n = 399 citations</a:t>
             </a:r>
           </a:p>
         </p:txBody>
@@ -11054,7 +11054,7 @@
         <p:spPr>
           <a:xfrm>
             <a:off x="762000" y="1206500"/>
-            <a:ext cx="3810000" cy="858520"/>
+            <a:ext cx="3810000" cy="924560"/>
           </a:xfrm>
           <a:prstGeom prst="rect">
             <a:avLst/>
@@ -11092,8 +11092,8 @@
         </p:nvSpPr>
         <p:spPr>
           <a:xfrm>
-            <a:off x="762000" y="2230120"/>
-            <a:ext cx="3810000" cy="462280"/>
+            <a:off x="762000" y="2296160"/>
+            <a:ext cx="3810000" cy="497839"/>
           </a:xfrm>
           <a:prstGeom prst="rect">
             <a:avLst/>
@@ -11298,7 +11298,7 @@
                 </a:solidFill>
                 <a:latin typeface="IBM Plex Mono"/>
               </a:rPr>
-              <a:t>source: data/processed/concentration.csv</a:t>
+              <a:t>source: data/processed/concentration.csv  ·  n = 199 and 200 citations</a:t>
             </a:r>
           </a:p>
         </p:txBody>
@@ -11426,7 +11426,7 @@
         <p:spPr>
           <a:xfrm>
             <a:off x="762000" y="1206500"/>
-            <a:ext cx="3810000" cy="1717040"/>
+            <a:ext cx="3810000" cy="1386839"/>
           </a:xfrm>
           <a:prstGeom prst="rect">
             <a:avLst/>
@@ -11451,7 +11451,7 @@
                 </a:solidFill>
                 <a:latin typeface="Work Sans"/>
               </a:rPr>
-              <a:t>Bank Jago and BCA take more of the answers than of their sources</a:t>
+              <a:t>Bank Mandiri gets less of the answers than its sources give it</a:t>
             </a:r>
           </a:p>
         </p:txBody>
@@ -11464,8 +11464,8 @@
         </p:nvSpPr>
         <p:spPr>
           <a:xfrm>
-            <a:off x="762000" y="3088640"/>
-            <a:ext cx="3810000" cy="693420"/>
+            <a:off x="762000" y="2758440"/>
+            <a:ext cx="3810000" cy="746760"/>
           </a:xfrm>
           <a:prstGeom prst="rect">
             <a:avLst/>
@@ -11490,7 +11490,7 @@
                 </a:solidFill>
                 <a:latin typeface="Work Sans"/>
               </a:rPr>
-              <a:t>Bank Jago holds 20.2% of bank mentions in the answers and 13.6% in the pages they cite.</a:t>
+              <a:t>Bank Mandiri holds 11.5% of bank mentions in the cited pages and 5.9% in the answers.</a:t>
             </a:r>
           </a:p>
         </p:txBody>
@@ -11503,8 +11503,8 @@
         </p:nvSpPr>
         <p:spPr>
           <a:xfrm>
-            <a:off x="762000" y="3870960"/>
-            <a:ext cx="3810000" cy="462280"/>
+            <a:off x="762000" y="3594100"/>
+            <a:ext cx="3810000" cy="746760"/>
           </a:xfrm>
           <a:prstGeom prst="rect">
             <a:avLst/>
@@ -11529,14 +11529,53 @@
                 </a:solidFill>
                 <a:latin typeface="Work Sans"/>
               </a:rPr>
-              <a:t>Bank Mandiri runs the other way: 11.5% in the pages, 5.9% in the answers.</a:t>
+              <a:t>Bank Jago and BCA lean the other way. Bank Jago holds 20.2% of mentions in the answers and 13.6% in the pages.</a:t>
+            </a:r>
+          </a:p>
+        </p:txBody>
+      </p:sp>
+      <p:sp>
+        <p:nvSpPr>
+          <p:cNvPr id="7" name="TextBox 6"/>
+          <p:cNvSpPr txBox="1"/>
+          <p:nvPr/>
+        </p:nvSpPr>
+        <p:spPr>
+          <a:xfrm>
+            <a:off x="762000" y="4429760"/>
+            <a:ext cx="3810000" cy="995679"/>
+          </a:xfrm>
+          <a:prstGeom prst="rect">
+            <a:avLst/>
+          </a:prstGeom>
+          <a:noFill/>
+        </p:spPr>
+        <p:txBody>
+          <a:bodyPr wrap="square" lIns="0" rIns="0" tIns="0" bIns="0" anchor="t">
+            <a:spAutoFit/>
+          </a:bodyPr>
+          <a:lstStyle/>
+          <a:p>
+            <a:pPr algn="l">
+              <a:lnSpc>
+                <a:spcPct val="115000"/>
+              </a:lnSpc>
+            </a:pPr>
+            <a:r>
+              <a:rPr sz="1400" b="0">
+                <a:solidFill>
+                  <a:srgbClr val="9A9EA6"/>
+                </a:solidFill>
+                <a:latin typeface="Work Sans"/>
+              </a:rPr>
+              <a:t>Pages were counted without a bare “Jago” or “blu”, so these two banks' source share may be low and their gaps too wide.</a:t>
             </a:r>
           </a:p>
         </p:txBody>
       </p:sp>
       <p:pic>
         <p:nvPicPr>
-          <p:cNvPr id="7" name="Picture 6" descr="sov_gap.png"/>
+          <p:cNvPr id="8" name="Picture 7" descr="sov_gap.png"/>
           <p:cNvPicPr>
             <a:picLocks noChangeAspect="1"/>
           </p:cNvPicPr>
@@ -11560,7 +11599,7 @@
       </p:pic>
       <p:sp>
         <p:nvSpPr>
-          <p:cNvPr id="8" name="TextBox 7"/>
+          <p:cNvPr id="9" name="TextBox 8"/>
           <p:cNvSpPr txBox="1"/>
           <p:nvPr/>
         </p:nvSpPr>
@@ -11599,7 +11638,7 @@
       </p:sp>
       <p:sp>
         <p:nvSpPr>
-          <p:cNvPr id="9" name="TextBox 8"/>
+          <p:cNvPr id="10" name="TextBox 9"/>
           <p:cNvSpPr txBox="1"/>
           <p:nvPr/>
         </p:nvSpPr>
@@ -11638,7 +11677,7 @@
       </p:sp>
       <p:sp>
         <p:nvSpPr>
-          <p:cNvPr id="10" name="TextBox 9"/>
+          <p:cNvPr id="11" name="TextBox 10"/>
           <p:cNvSpPr txBox="1"/>
           <p:nvPr/>
         </p:nvSpPr>
@@ -11677,7 +11716,7 @@
       </p:sp>
       <p:sp>
         <p:nvSpPr>
-          <p:cNvPr id="11" name="TextBox 10"/>
+          <p:cNvPr id="12" name="TextBox 11"/>
           <p:cNvSpPr txBox="1"/>
           <p:nvPr/>
         </p:nvSpPr>
@@ -11709,7 +11748,7 @@
                 </a:solidFill>
                 <a:latin typeface="IBM Plex Mono"/>
               </a:rPr>
-              <a:t>source: data/processed/source_sov.csv  ·  answers weighted equally, pages weighted equally</a:t>
+              <a:t>source: data/processed/source_sov.csv  ·  answers and pages weighted equally  ·  n = 40 answers, 148 pages</a:t>
             </a:r>
           </a:p>
         </p:txBody>
@@ -11837,7 +11876,7 @@
         <p:spPr>
           <a:xfrm>
             <a:off x="762000" y="1206500"/>
-            <a:ext cx="3810000" cy="1287780"/>
+            <a:ext cx="3810000" cy="1386839"/>
           </a:xfrm>
           <a:prstGeom prst="rect">
             <a:avLst/>
@@ -11875,8 +11914,8 @@
         </p:nvSpPr>
         <p:spPr>
           <a:xfrm>
-            <a:off x="762000" y="2659380"/>
-            <a:ext cx="3810000" cy="693420"/>
+            <a:off x="762000" y="2758440"/>
+            <a:ext cx="3810000" cy="746760"/>
           </a:xfrm>
           <a:prstGeom prst="rect">
             <a:avLst/>
@@ -11914,8 +11953,8 @@
         </p:nvSpPr>
         <p:spPr>
           <a:xfrm>
-            <a:off x="762000" y="3441700"/>
-            <a:ext cx="3810000" cy="693420"/>
+            <a:off x="762000" y="3594100"/>
+            <a:ext cx="3810000" cy="746760"/>
           </a:xfrm>
           <a:prstGeom prst="rect">
             <a:avLst/>
@@ -12120,7 +12159,7 @@
                 </a:solidFill>
                 <a:latin typeface="IBM Plex Mono"/>
               </a:rPr>
-              <a:t>source: data/interim/citations.csv, pages.csv</a:t>
+              <a:t>source: data/interim/citations.csv, pages.csv  ·  n = 200 Gemini citations</a:t>
             </a:r>
           </a:p>
         </p:txBody>
@@ -12248,7 +12287,7 @@
         <p:spPr>
           <a:xfrm>
             <a:off x="762000" y="1206500"/>
-            <a:ext cx="3810000" cy="858520"/>
+            <a:ext cx="3810000" cy="924560"/>
           </a:xfrm>
           <a:prstGeom prst="rect">
             <a:avLst/>
@@ -12286,8 +12325,8 @@
         </p:nvSpPr>
         <p:spPr>
           <a:xfrm>
-            <a:off x="762000" y="2230120"/>
-            <a:ext cx="3810000" cy="693420"/>
+            <a:off x="762000" y="2296160"/>
+            <a:ext cx="3810000" cy="746760"/>
           </a:xfrm>
           <a:prstGeom prst="rect">
             <a:avLst/>
@@ -12325,8 +12364,8 @@
         </p:nvSpPr>
         <p:spPr>
           <a:xfrm>
-            <a:off x="762000" y="3012440"/>
-            <a:ext cx="3810000" cy="462280"/>
+            <a:off x="762000" y="3131820"/>
+            <a:ext cx="3810000" cy="497839"/>
           </a:xfrm>
           <a:prstGeom prst="rect">
             <a:avLst/>
@@ -12364,8 +12403,8 @@
         </p:nvSpPr>
         <p:spPr>
           <a:xfrm>
-            <a:off x="762000" y="3563620"/>
-            <a:ext cx="3810000" cy="693420"/>
+            <a:off x="762000" y="3718560"/>
+            <a:ext cx="3810000" cy="746760"/>
           </a:xfrm>
           <a:prstGeom prst="rect">
             <a:avLst/>
@@ -12570,7 +12609,7 @@
                 </a:solidFill>
                 <a:latin typeface="IBM Plex Mono"/>
               </a:rPr>
-              <a:t>source: data/processed/schema.csv, recency.csv  ·  Google Search Central, AI features and your website</a:t>
+              <a:t>source: data/processed/schema.csv, recency.csv  ·  Google Search Central  ·  n = 191 pages, 333 citations</a:t>
             </a:r>
           </a:p>
         </p:txBody>
@@ -12649,7 +12688,7 @@
         <p:spPr>
           <a:xfrm>
             <a:off x="0" y="2794000"/>
-            <a:ext cx="12192000" cy="990600"/>
+            <a:ext cx="12192000" cy="1066800"/>
           </a:xfrm>
           <a:prstGeom prst="rect">
             <a:avLst/>
@@ -12688,7 +12727,7 @@
         <p:spPr>
           <a:xfrm>
             <a:off x="0" y="3937000"/>
-            <a:ext cx="12192000" cy="317500"/>
+            <a:ext cx="12192000" cy="320040"/>
           </a:xfrm>
           <a:prstGeom prst="rect">
             <a:avLst/>
@@ -12911,7 +12950,7 @@
         <p:spPr>
           <a:xfrm>
             <a:off x="762000" y="1270000"/>
-            <a:ext cx="10668000" cy="495300"/>
+            <a:ext cx="10668000" cy="533400"/>
           </a:xfrm>
           <a:prstGeom prst="rect">
             <a:avLst/>
@@ -12949,8 +12988,8 @@
         </p:nvSpPr>
         <p:spPr>
           <a:xfrm>
-            <a:off x="762000" y="2006600"/>
-            <a:ext cx="571500" cy="215900"/>
+            <a:off x="762000" y="2044700"/>
+            <a:ext cx="571500" cy="231140"/>
           </a:xfrm>
           <a:prstGeom prst="rect">
             <a:avLst/>
@@ -12988,8 +13027,8 @@
         </p:nvSpPr>
         <p:spPr>
           <a:xfrm>
-            <a:off x="1460500" y="1981200"/>
-            <a:ext cx="8636000" cy="561340"/>
+            <a:off x="1460500" y="2019300"/>
+            <a:ext cx="8636000" cy="604519"/>
           </a:xfrm>
           <a:prstGeom prst="rect">
             <a:avLst/>
@@ -13027,8 +13066,8 @@
         </p:nvSpPr>
         <p:spPr>
           <a:xfrm>
-            <a:off x="762000" y="2707640"/>
-            <a:ext cx="571500" cy="215900"/>
+            <a:off x="762000" y="2788920"/>
+            <a:ext cx="571500" cy="231140"/>
           </a:xfrm>
           <a:prstGeom prst="rect">
             <a:avLst/>
@@ -13066,8 +13105,8 @@
         </p:nvSpPr>
         <p:spPr>
           <a:xfrm>
-            <a:off x="1460500" y="2682240"/>
-            <a:ext cx="8636000" cy="561340"/>
+            <a:off x="1460500" y="2763520"/>
+            <a:ext cx="8636000" cy="604519"/>
           </a:xfrm>
           <a:prstGeom prst="rect">
             <a:avLst/>
@@ -13105,8 +13144,8 @@
         </p:nvSpPr>
         <p:spPr>
           <a:xfrm>
-            <a:off x="762000" y="3408679"/>
-            <a:ext cx="571500" cy="215900"/>
+            <a:off x="762000" y="3533140"/>
+            <a:ext cx="571500" cy="231140"/>
           </a:xfrm>
           <a:prstGeom prst="rect">
             <a:avLst/>
@@ -13144,8 +13183,8 @@
         </p:nvSpPr>
         <p:spPr>
           <a:xfrm>
-            <a:off x="1460500" y="3383279"/>
-            <a:ext cx="8636000" cy="561340"/>
+            <a:off x="1460500" y="3507740"/>
+            <a:ext cx="8636000" cy="604519"/>
           </a:xfrm>
           <a:prstGeom prst="rect">
             <a:avLst/>
@@ -13170,7 +13209,7 @@
                 </a:solidFill>
                 <a:latin typeface="Work Sans"/>
               </a:rPr>
-              <a:t>Know what the comparison articles say about you. Akulaku, Zaipad and Fazz appear in 13 to 15 of Gemini's 20 answers.</a:t>
+              <a:t>Know what the comparison sites say about you. Gemini cites Akulaku's, Zaipad's and Fazz's sites in 13 to 15 of its 20 answers.</a:t>
             </a:r>
           </a:p>
         </p:txBody>
@@ -13183,8 +13222,8 @@
         </p:nvSpPr>
         <p:spPr>
           <a:xfrm>
-            <a:off x="762000" y="4109719"/>
-            <a:ext cx="571500" cy="215900"/>
+            <a:off x="762000" y="4277359"/>
+            <a:ext cx="571500" cy="231140"/>
           </a:xfrm>
           <a:prstGeom prst="rect">
             <a:avLst/>
@@ -13222,8 +13261,8 @@
         </p:nvSpPr>
         <p:spPr>
           <a:xfrm>
-            <a:off x="1460500" y="4084319"/>
-            <a:ext cx="8636000" cy="280670"/>
+            <a:off x="1460500" y="4251959"/>
+            <a:ext cx="8636000" cy="302259"/>
           </a:xfrm>
           <a:prstGeom prst="rect">
             <a:avLst/>
@@ -13261,8 +13300,8 @@
         </p:nvSpPr>
         <p:spPr>
           <a:xfrm>
-            <a:off x="762000" y="4530090"/>
-            <a:ext cx="571500" cy="215900"/>
+            <a:off x="762000" y="4719320"/>
+            <a:ext cx="571500" cy="231140"/>
           </a:xfrm>
           <a:prstGeom prst="rect">
             <a:avLst/>
@@ -13300,8 +13339,8 @@
         </p:nvSpPr>
         <p:spPr>
           <a:xfrm>
-            <a:off x="1460500" y="4504690"/>
-            <a:ext cx="8636000" cy="280670"/>
+            <a:off x="1460500" y="4693920"/>
+            <a:ext cx="8636000" cy="302259"/>
           </a:xfrm>
           <a:prstGeom prst="rect">
             <a:avLst/>
@@ -13571,7 +13610,7 @@
         <p:spPr>
           <a:xfrm>
             <a:off x="762000" y="1270000"/>
-            <a:ext cx="10668000" cy="495300"/>
+            <a:ext cx="10668000" cy="533400"/>
           </a:xfrm>
           <a:prstGeom prst="rect">
             <a:avLst/>
@@ -13609,8 +13648,8 @@
         </p:nvSpPr>
         <p:spPr>
           <a:xfrm>
-            <a:off x="762000" y="2006600"/>
-            <a:ext cx="571500" cy="215900"/>
+            <a:off x="762000" y="2044700"/>
+            <a:ext cx="571500" cy="231140"/>
           </a:xfrm>
           <a:prstGeom prst="rect">
             <a:avLst/>
@@ -13648,8 +13687,8 @@
         </p:nvSpPr>
         <p:spPr>
           <a:xfrm>
-            <a:off x="1460500" y="1981200"/>
-            <a:ext cx="8636000" cy="264160"/>
+            <a:off x="1460500" y="2019300"/>
+            <a:ext cx="8636000" cy="284480"/>
           </a:xfrm>
           <a:prstGeom prst="rect">
             <a:avLst/>
@@ -13687,8 +13726,8 @@
         </p:nvSpPr>
         <p:spPr>
           <a:xfrm>
-            <a:off x="762000" y="2397760"/>
-            <a:ext cx="571500" cy="215900"/>
+            <a:off x="762000" y="2456180"/>
+            <a:ext cx="571500" cy="231140"/>
           </a:xfrm>
           <a:prstGeom prst="rect">
             <a:avLst/>
@@ -13726,8 +13765,8 @@
         </p:nvSpPr>
         <p:spPr>
           <a:xfrm>
-            <a:off x="1460500" y="2372360"/>
-            <a:ext cx="8636000" cy="264160"/>
+            <a:off x="1460500" y="2430780"/>
+            <a:ext cx="8636000" cy="284480"/>
           </a:xfrm>
           <a:prstGeom prst="rect">
             <a:avLst/>
@@ -13765,8 +13804,8 @@
         </p:nvSpPr>
         <p:spPr>
           <a:xfrm>
-            <a:off x="762000" y="2788920"/>
-            <a:ext cx="571500" cy="215900"/>
+            <a:off x="762000" y="2867660"/>
+            <a:ext cx="571500" cy="231140"/>
           </a:xfrm>
           <a:prstGeom prst="rect">
             <a:avLst/>
@@ -13804,8 +13843,8 @@
         </p:nvSpPr>
         <p:spPr>
           <a:xfrm>
-            <a:off x="1460500" y="2763520"/>
-            <a:ext cx="8636000" cy="528320"/>
+            <a:off x="1460500" y="2842260"/>
+            <a:ext cx="8636000" cy="568960"/>
           </a:xfrm>
           <a:prstGeom prst="rect">
             <a:avLst/>
@@ -13843,8 +13882,8 @@
         </p:nvSpPr>
         <p:spPr>
           <a:xfrm>
-            <a:off x="762000" y="3444240"/>
-            <a:ext cx="571500" cy="215900"/>
+            <a:off x="762000" y="3563620"/>
+            <a:ext cx="571500" cy="231140"/>
           </a:xfrm>
           <a:prstGeom prst="rect">
             <a:avLst/>
@@ -13882,8 +13921,8 @@
         </p:nvSpPr>
         <p:spPr>
           <a:xfrm>
-            <a:off x="1460500" y="3418840"/>
-            <a:ext cx="8636000" cy="264160"/>
+            <a:off x="1460500" y="3538220"/>
+            <a:ext cx="8636000" cy="284480"/>
           </a:xfrm>
           <a:prstGeom prst="rect">
             <a:avLst/>
@@ -13921,8 +13960,8 @@
         </p:nvSpPr>
         <p:spPr>
           <a:xfrm>
-            <a:off x="762000" y="3835400"/>
-            <a:ext cx="571500" cy="215900"/>
+            <a:off x="762000" y="3975100"/>
+            <a:ext cx="571500" cy="231140"/>
           </a:xfrm>
           <a:prstGeom prst="rect">
             <a:avLst/>
@@ -13960,8 +13999,8 @@
         </p:nvSpPr>
         <p:spPr>
           <a:xfrm>
-            <a:off x="1460500" y="3810000"/>
-            <a:ext cx="8636000" cy="528320"/>
+            <a:off x="1460500" y="3949700"/>
+            <a:ext cx="8636000" cy="568960"/>
           </a:xfrm>
           <a:prstGeom prst="rect">
             <a:avLst/>
@@ -13999,8 +14038,8 @@
         </p:nvSpPr>
         <p:spPr>
           <a:xfrm>
-            <a:off x="762000" y="4490720"/>
-            <a:ext cx="571500" cy="215900"/>
+            <a:off x="762000" y="4671060"/>
+            <a:ext cx="571500" cy="231140"/>
           </a:xfrm>
           <a:prstGeom prst="rect">
             <a:avLst/>
@@ -14038,8 +14077,8 @@
         </p:nvSpPr>
         <p:spPr>
           <a:xfrm>
-            <a:off x="1460500" y="4465320"/>
-            <a:ext cx="8636000" cy="528320"/>
+            <a:off x="1460500" y="4645660"/>
+            <a:ext cx="8636000" cy="568960"/>
           </a:xfrm>
           <a:prstGeom prst="rect">
             <a:avLst/>
@@ -14221,7 +14260,7 @@
         <p:spPr>
           <a:xfrm>
             <a:off x="762000" y="1079500"/>
-            <a:ext cx="9525000" cy="858520"/>
+            <a:ext cx="9525000" cy="924560"/>
           </a:xfrm>
           <a:prstGeom prst="rect">
             <a:avLst/>
@@ -14260,7 +14299,7 @@
         <p:spPr>
           <a:xfrm>
             <a:off x="762000" y="2476500"/>
-            <a:ext cx="5207000" cy="1270000"/>
+            <a:ext cx="5207000" cy="1280160"/>
           </a:xfrm>
           <a:prstGeom prst="rect">
             <a:avLst/>
@@ -14299,7 +14338,7 @@
         <p:spPr>
           <a:xfrm>
             <a:off x="762000" y="3810000"/>
-            <a:ext cx="4572000" cy="528320"/>
+            <a:ext cx="4572000" cy="568960"/>
           </a:xfrm>
           <a:prstGeom prst="rect">
             <a:avLst/>
@@ -14377,7 +14416,7 @@
         <p:spPr>
           <a:xfrm>
             <a:off x="6223000" y="2476500"/>
-            <a:ext cx="5207000" cy="1270000"/>
+            <a:ext cx="5207000" cy="1280160"/>
           </a:xfrm>
           <a:prstGeom prst="rect">
             <a:avLst/>
@@ -14416,7 +14455,7 @@
         <p:spPr>
           <a:xfrm>
             <a:off x="6223000" y="3810000"/>
-            <a:ext cx="4572000" cy="528320"/>
+            <a:ext cx="4572000" cy="568960"/>
           </a:xfrm>
           <a:prstGeom prst="rect">
             <a:avLst/>
@@ -14678,7 +14717,7 @@
         <p:spPr>
           <a:xfrm>
             <a:off x="762000" y="1270000"/>
-            <a:ext cx="10668000" cy="495300"/>
+            <a:ext cx="10668000" cy="533400"/>
           </a:xfrm>
           <a:prstGeom prst="rect">
             <a:avLst/>
@@ -14716,8 +14755,8 @@
         </p:nvSpPr>
         <p:spPr>
           <a:xfrm>
-            <a:off x="762000" y="1981200"/>
-            <a:ext cx="9334500" cy="561340"/>
+            <a:off x="762000" y="2019300"/>
+            <a:ext cx="9334500" cy="604519"/>
           </a:xfrm>
           <a:prstGeom prst="rect">
             <a:avLst/>
@@ -14755,8 +14794,8 @@
         </p:nvSpPr>
         <p:spPr>
           <a:xfrm>
-            <a:off x="762000" y="2682240"/>
-            <a:ext cx="9334500" cy="561340"/>
+            <a:off x="762000" y="2763520"/>
+            <a:ext cx="9334500" cy="604519"/>
           </a:xfrm>
           <a:prstGeom prst="rect">
             <a:avLst/>
@@ -15026,7 +15065,7 @@
         <p:spPr>
           <a:xfrm>
             <a:off x="762000" y="1270000"/>
-            <a:ext cx="10668000" cy="495300"/>
+            <a:ext cx="10668000" cy="533400"/>
           </a:xfrm>
           <a:prstGeom prst="rect">
             <a:avLst/>
@@ -15064,8 +15103,8 @@
         </p:nvSpPr>
         <p:spPr>
           <a:xfrm>
-            <a:off x="762000" y="2006600"/>
-            <a:ext cx="571500" cy="215900"/>
+            <a:off x="762000" y="2044700"/>
+            <a:ext cx="571500" cy="231140"/>
           </a:xfrm>
           <a:prstGeom prst="rect">
             <a:avLst/>
@@ -15103,8 +15142,8 @@
         </p:nvSpPr>
         <p:spPr>
           <a:xfrm>
-            <a:off x="1460500" y="1981200"/>
-            <a:ext cx="8636000" cy="561340"/>
+            <a:off x="1460500" y="2019300"/>
+            <a:ext cx="8636000" cy="604519"/>
           </a:xfrm>
           <a:prstGeom prst="rect">
             <a:avLst/>
@@ -15142,8 +15181,8 @@
         </p:nvSpPr>
         <p:spPr>
           <a:xfrm>
-            <a:off x="762000" y="2707640"/>
-            <a:ext cx="571500" cy="215900"/>
+            <a:off x="762000" y="2788920"/>
+            <a:ext cx="571500" cy="231140"/>
           </a:xfrm>
           <a:prstGeom prst="rect">
             <a:avLst/>
@@ -15181,8 +15220,8 @@
         </p:nvSpPr>
         <p:spPr>
           <a:xfrm>
-            <a:off x="1460500" y="2682240"/>
-            <a:ext cx="8636000" cy="280670"/>
+            <a:off x="1460500" y="2763520"/>
+            <a:ext cx="8636000" cy="302259"/>
           </a:xfrm>
           <a:prstGeom prst="rect">
             <a:avLst/>
@@ -15220,8 +15259,8 @@
         </p:nvSpPr>
         <p:spPr>
           <a:xfrm>
-            <a:off x="762000" y="3128010"/>
-            <a:ext cx="571500" cy="215900"/>
+            <a:off x="762000" y="3230879"/>
+            <a:ext cx="571500" cy="231140"/>
           </a:xfrm>
           <a:prstGeom prst="rect">
             <a:avLst/>
@@ -15259,8 +15298,8 @@
         </p:nvSpPr>
         <p:spPr>
           <a:xfrm>
-            <a:off x="1460500" y="3102610"/>
-            <a:ext cx="8636000" cy="561340"/>
+            <a:off x="1460500" y="3205479"/>
+            <a:ext cx="8636000" cy="604519"/>
           </a:xfrm>
           <a:prstGeom prst="rect">
             <a:avLst/>
@@ -15298,8 +15337,8 @@
         </p:nvSpPr>
         <p:spPr>
           <a:xfrm>
-            <a:off x="762000" y="3829050"/>
-            <a:ext cx="571500" cy="215900"/>
+            <a:off x="762000" y="3975100"/>
+            <a:ext cx="571500" cy="231140"/>
           </a:xfrm>
           <a:prstGeom prst="rect">
             <a:avLst/>
@@ -15337,8 +15376,8 @@
         </p:nvSpPr>
         <p:spPr>
           <a:xfrm>
-            <a:off x="1460500" y="3803650"/>
-            <a:ext cx="8636000" cy="280670"/>
+            <a:off x="1460500" y="3949700"/>
+            <a:ext cx="8636000" cy="302259"/>
           </a:xfrm>
           <a:prstGeom prst="rect">
             <a:avLst/>
@@ -15520,7 +15559,7 @@
         <p:spPr>
           <a:xfrm>
             <a:off x="762000" y="1079500"/>
-            <a:ext cx="10160000" cy="1320800"/>
+            <a:ext cx="10160000" cy="1422400"/>
           </a:xfrm>
           <a:prstGeom prst="rect">
             <a:avLst/>
@@ -15559,7 +15598,7 @@
         <p:spPr>
           <a:xfrm>
             <a:off x="762000" y="1841500"/>
-            <a:ext cx="10160000" cy="264160"/>
+            <a:ext cx="10160000" cy="284480"/>
           </a:xfrm>
           <a:prstGeom prst="rect">
             <a:avLst/>
@@ -15637,7 +15676,7 @@
         <p:spPr>
           <a:xfrm>
             <a:off x="762000" y="2819400"/>
-            <a:ext cx="9525000" cy="181610"/>
+            <a:ext cx="9525000" cy="195579"/>
           </a:xfrm>
           <a:prstGeom prst="rect">
             <a:avLst/>
@@ -15676,7 +15715,7 @@
         <p:spPr>
           <a:xfrm>
             <a:off x="762000" y="3048000"/>
-            <a:ext cx="9525000" cy="181610"/>
+            <a:ext cx="9525000" cy="195579"/>
           </a:xfrm>
           <a:prstGeom prst="rect">
             <a:avLst/>
@@ -15715,7 +15754,7 @@
         <p:spPr>
           <a:xfrm>
             <a:off x="762000" y="3276600"/>
-            <a:ext cx="9525000" cy="181610"/>
+            <a:ext cx="9525000" cy="195579"/>
           </a:xfrm>
           <a:prstGeom prst="rect">
             <a:avLst/>
@@ -15754,7 +15793,7 @@
         <p:spPr>
           <a:xfrm>
             <a:off x="762000" y="3505200"/>
-            <a:ext cx="9525000" cy="181610"/>
+            <a:ext cx="9525000" cy="195579"/>
           </a:xfrm>
           <a:prstGeom prst="rect">
             <a:avLst/>
@@ -15793,7 +15832,7 @@
         <p:spPr>
           <a:xfrm>
             <a:off x="762000" y="3733800"/>
-            <a:ext cx="9525000" cy="181610"/>
+            <a:ext cx="9525000" cy="195579"/>
           </a:xfrm>
           <a:prstGeom prst="rect">
             <a:avLst/>
@@ -15832,7 +15871,7 @@
         <p:spPr>
           <a:xfrm>
             <a:off x="762000" y="3962400"/>
-            <a:ext cx="9525000" cy="181610"/>
+            <a:ext cx="9525000" cy="195579"/>
           </a:xfrm>
           <a:prstGeom prst="rect">
             <a:avLst/>
@@ -15871,7 +15910,7 @@
         <p:spPr>
           <a:xfrm>
             <a:off x="762000" y="4191000"/>
-            <a:ext cx="9525000" cy="181610"/>
+            <a:ext cx="9525000" cy="195579"/>
           </a:xfrm>
           <a:prstGeom prst="rect">
             <a:avLst/>
@@ -15910,7 +15949,7 @@
         <p:spPr>
           <a:xfrm>
             <a:off x="762000" y="4419600"/>
-            <a:ext cx="9525000" cy="181610"/>
+            <a:ext cx="9525000" cy="195579"/>
           </a:xfrm>
           <a:prstGeom prst="rect">
             <a:avLst/>
@@ -16172,7 +16211,7 @@
         <p:spPr>
           <a:xfrm>
             <a:off x="762000" y="1270000"/>
-            <a:ext cx="10668000" cy="495300"/>
+            <a:ext cx="10668000" cy="533400"/>
           </a:xfrm>
           <a:prstGeom prst="rect">
             <a:avLst/>
@@ -16210,8 +16249,8 @@
         </p:nvSpPr>
         <p:spPr>
           <a:xfrm>
-            <a:off x="762000" y="2006600"/>
-            <a:ext cx="571500" cy="215900"/>
+            <a:off x="762000" y="2044700"/>
+            <a:ext cx="571500" cy="231140"/>
           </a:xfrm>
           <a:prstGeom prst="rect">
             <a:avLst/>
@@ -16249,8 +16288,8 @@
         </p:nvSpPr>
         <p:spPr>
           <a:xfrm>
-            <a:off x="1460500" y="1981200"/>
-            <a:ext cx="8636000" cy="280670"/>
+            <a:off x="1460500" y="2019300"/>
+            <a:ext cx="8636000" cy="302259"/>
           </a:xfrm>
           <a:prstGeom prst="rect">
             <a:avLst/>
@@ -16288,8 +16327,8 @@
         </p:nvSpPr>
         <p:spPr>
           <a:xfrm>
-            <a:off x="762000" y="2426970"/>
-            <a:ext cx="571500" cy="215900"/>
+            <a:off x="762000" y="2486660"/>
+            <a:ext cx="571500" cy="231140"/>
           </a:xfrm>
           <a:prstGeom prst="rect">
             <a:avLst/>
@@ -16327,8 +16366,8 @@
         </p:nvSpPr>
         <p:spPr>
           <a:xfrm>
-            <a:off x="1460500" y="2401570"/>
-            <a:ext cx="8636000" cy="280670"/>
+            <a:off x="1460500" y="2461260"/>
+            <a:ext cx="8636000" cy="302259"/>
           </a:xfrm>
           <a:prstGeom prst="rect">
             <a:avLst/>
@@ -16366,8 +16405,8 @@
         </p:nvSpPr>
         <p:spPr>
           <a:xfrm>
-            <a:off x="762000" y="2847340"/>
-            <a:ext cx="571500" cy="215900"/>
+            <a:off x="762000" y="2928620"/>
+            <a:ext cx="571500" cy="231140"/>
           </a:xfrm>
           <a:prstGeom prst="rect">
             <a:avLst/>
@@ -16405,8 +16444,8 @@
         </p:nvSpPr>
         <p:spPr>
           <a:xfrm>
-            <a:off x="1460500" y="2821940"/>
-            <a:ext cx="8636000" cy="561340"/>
+            <a:off x="1460500" y="2903220"/>
+            <a:ext cx="8636000" cy="604519"/>
           </a:xfrm>
           <a:prstGeom prst="rect">
             <a:avLst/>
@@ -16627,7 +16666,7 @@
         <p:spPr>
           <a:xfrm>
             <a:off x="0" y="2794000"/>
-            <a:ext cx="12192000" cy="990600"/>
+            <a:ext cx="12192000" cy="1066800"/>
           </a:xfrm>
           <a:prstGeom prst="rect">
             <a:avLst/>
@@ -16666,7 +16705,7 @@
         <p:spPr>
           <a:xfrm>
             <a:off x="0" y="3937000"/>
-            <a:ext cx="12192000" cy="317500"/>
+            <a:ext cx="12192000" cy="320040"/>
           </a:xfrm>
           <a:prstGeom prst="rect">
             <a:avLst/>
@@ -16889,7 +16928,7 @@
         <p:spPr>
           <a:xfrm>
             <a:off x="762000" y="1206500"/>
-            <a:ext cx="3810000" cy="1287780"/>
+            <a:ext cx="3810000" cy="1386839"/>
           </a:xfrm>
           <a:prstGeom prst="rect">
             <a:avLst/>
@@ -16927,8 +16966,8 @@
         </p:nvSpPr>
         <p:spPr>
           <a:xfrm>
-            <a:off x="762000" y="2659380"/>
-            <a:ext cx="3810000" cy="693420"/>
+            <a:off x="762000" y="2758440"/>
+            <a:ext cx="3810000" cy="746760"/>
           </a:xfrm>
           <a:prstGeom prst="rect">
             <a:avLst/>
@@ -16966,8 +17005,8 @@
         </p:nvSpPr>
         <p:spPr>
           <a:xfrm>
-            <a:off x="762000" y="3441700"/>
-            <a:ext cx="3810000" cy="693420"/>
+            <a:off x="762000" y="3594100"/>
+            <a:ext cx="3810000" cy="746760"/>
           </a:xfrm>
           <a:prstGeom prst="rect">
             <a:avLst/>
@@ -17005,8 +17044,8 @@
         </p:nvSpPr>
         <p:spPr>
           <a:xfrm>
-            <a:off x="762000" y="4224020"/>
-            <a:ext cx="3810000" cy="231140"/>
+            <a:off x="762000" y="4429760"/>
+            <a:ext cx="3810000" cy="248919"/>
           </a:xfrm>
           <a:prstGeom prst="rect">
             <a:avLst/>
@@ -17211,7 +17250,7 @@
                 </a:solidFill>
                 <a:latin typeface="IBM Plex Mono"/>
               </a:rPr>
-              <a:t>source: data/interim/answers.csv</a:t>
+              <a:t>source: data/interim/answers.csv  ·  n = 20 prompts</a:t>
             </a:r>
           </a:p>
         </p:txBody>
@@ -17339,7 +17378,7 @@
         <p:spPr>
           <a:xfrm>
             <a:off x="762000" y="1181100"/>
-            <a:ext cx="10668000" cy="429260"/>
+            <a:ext cx="10668000" cy="462280"/>
           </a:xfrm>
           <a:prstGeom prst="rect">
             <a:avLst/>
@@ -17377,8 +17416,8 @@
         </p:nvSpPr>
         <p:spPr>
           <a:xfrm>
-            <a:off x="762000" y="1699260"/>
-            <a:ext cx="8572500" cy="462280"/>
+            <a:off x="762000" y="1732280"/>
+            <a:ext cx="8572500" cy="497839"/>
           </a:xfrm>
           <a:prstGeom prst="rect">
             <a:avLst/>
@@ -17424,8 +17463,8 @@
         </p:blipFill>
         <p:spPr>
           <a:xfrm>
-            <a:off x="1441196" y="2275840"/>
-            <a:ext cx="9309607" cy="3324859"/>
+            <a:off x="1537208" y="2344420"/>
+            <a:ext cx="9117584" cy="3256279"/>
           </a:xfrm>
           <a:prstGeom prst="rect">
             <a:avLst/>
@@ -17583,7 +17622,7 @@
                 </a:solidFill>
                 <a:latin typeface="IBM Plex Mono"/>
               </a:rPr>
-              <a:t>code and data: github.com/rgmwnn/geo-bank-visibility</a:t>
+              <a:t>code and data: github.com/rgmwnn/geo-bank-visibility  ·  n = 40 answers</a:t>
             </a:r>
           </a:p>
         </p:txBody>
@@ -17711,7 +17750,7 @@
         <p:spPr>
           <a:xfrm>
             <a:off x="762000" y="1181100"/>
-            <a:ext cx="10668000" cy="429260"/>
+            <a:ext cx="10668000" cy="462280"/>
           </a:xfrm>
           <a:prstGeom prst="rect">
             <a:avLst/>
@@ -17749,8 +17788,8 @@
         </p:nvSpPr>
         <p:spPr>
           <a:xfrm>
-            <a:off x="762000" y="1724660"/>
-            <a:ext cx="5207000" cy="231140"/>
+            <a:off x="762000" y="1757680"/>
+            <a:ext cx="5207000" cy="248919"/>
           </a:xfrm>
           <a:prstGeom prst="rect">
             <a:avLst/>
@@ -17788,8 +17827,8 @@
         </p:nvSpPr>
         <p:spPr>
           <a:xfrm>
-            <a:off x="762000" y="1953260"/>
-            <a:ext cx="5207000" cy="198120"/>
+            <a:off x="762000" y="1986280"/>
+            <a:ext cx="5207000" cy="213359"/>
           </a:xfrm>
           <a:prstGeom prst="rect">
             <a:avLst/>
@@ -17827,8 +17866,8 @@
         </p:nvSpPr>
         <p:spPr>
           <a:xfrm>
-            <a:off x="762000" y="2227580"/>
-            <a:ext cx="5207000" cy="231140"/>
+            <a:off x="762000" y="2275840"/>
+            <a:ext cx="5207000" cy="248919"/>
           </a:xfrm>
           <a:prstGeom prst="rect">
             <a:avLst/>
@@ -17866,8 +17905,8 @@
         </p:nvSpPr>
         <p:spPr>
           <a:xfrm>
-            <a:off x="762000" y="2456180"/>
-            <a:ext cx="5207000" cy="198120"/>
+            <a:off x="762000" y="2504440"/>
+            <a:ext cx="5207000" cy="213359"/>
           </a:xfrm>
           <a:prstGeom prst="rect">
             <a:avLst/>
@@ -17905,8 +17944,8 @@
         </p:nvSpPr>
         <p:spPr>
           <a:xfrm>
-            <a:off x="762000" y="2730500"/>
-            <a:ext cx="5207000" cy="231140"/>
+            <a:off x="762000" y="2794000"/>
+            <a:ext cx="5207000" cy="248919"/>
           </a:xfrm>
           <a:prstGeom prst="rect">
             <a:avLst/>
@@ -17944,8 +17983,8 @@
         </p:nvSpPr>
         <p:spPr>
           <a:xfrm>
-            <a:off x="762000" y="2959100"/>
-            <a:ext cx="5207000" cy="396240"/>
+            <a:off x="762000" y="3022600"/>
+            <a:ext cx="5207000" cy="426719"/>
           </a:xfrm>
           <a:prstGeom prst="rect">
             <a:avLst/>
@@ -17983,8 +18022,8 @@
         </p:nvSpPr>
         <p:spPr>
           <a:xfrm>
-            <a:off x="762000" y="3431540"/>
-            <a:ext cx="5207000" cy="231140"/>
+            <a:off x="762000" y="3525520"/>
+            <a:ext cx="5207000" cy="248919"/>
           </a:xfrm>
           <a:prstGeom prst="rect">
             <a:avLst/>
@@ -18022,8 +18061,8 @@
         </p:nvSpPr>
         <p:spPr>
           <a:xfrm>
-            <a:off x="762000" y="3660140"/>
-            <a:ext cx="5207000" cy="198120"/>
+            <a:off x="762000" y="3754120"/>
+            <a:ext cx="5207000" cy="213359"/>
           </a:xfrm>
           <a:prstGeom prst="rect">
             <a:avLst/>
@@ -18061,8 +18100,8 @@
         </p:nvSpPr>
         <p:spPr>
           <a:xfrm>
-            <a:off x="762000" y="3934460"/>
-            <a:ext cx="5207000" cy="231140"/>
+            <a:off x="762000" y="4043680"/>
+            <a:ext cx="5207000" cy="248919"/>
           </a:xfrm>
           <a:prstGeom prst="rect">
             <a:avLst/>
@@ -18100,8 +18139,8 @@
         </p:nvSpPr>
         <p:spPr>
           <a:xfrm>
-            <a:off x="762000" y="4163060"/>
-            <a:ext cx="5207000" cy="198120"/>
+            <a:off x="762000" y="4272280"/>
+            <a:ext cx="5207000" cy="213359"/>
           </a:xfrm>
           <a:prstGeom prst="rect">
             <a:avLst/>
@@ -18139,8 +18178,8 @@
         </p:nvSpPr>
         <p:spPr>
           <a:xfrm>
-            <a:off x="762000" y="4437380"/>
-            <a:ext cx="5207000" cy="231140"/>
+            <a:off x="762000" y="4561840"/>
+            <a:ext cx="5207000" cy="248919"/>
           </a:xfrm>
           <a:prstGeom prst="rect">
             <a:avLst/>
@@ -18178,8 +18217,8 @@
         </p:nvSpPr>
         <p:spPr>
           <a:xfrm>
-            <a:off x="762000" y="4665980"/>
-            <a:ext cx="5207000" cy="396240"/>
+            <a:off x="762000" y="4790440"/>
+            <a:ext cx="5207000" cy="426719"/>
           </a:xfrm>
           <a:prstGeom prst="rect">
             <a:avLst/>
@@ -18512,7 +18551,7 @@
         <p:spPr>
           <a:xfrm>
             <a:off x="762000" y="1206500"/>
-            <a:ext cx="3810000" cy="858520"/>
+            <a:ext cx="3810000" cy="924560"/>
           </a:xfrm>
           <a:prstGeom prst="rect">
             <a:avLst/>
@@ -18550,8 +18589,8 @@
         </p:nvSpPr>
         <p:spPr>
           <a:xfrm>
-            <a:off x="762000" y="2230120"/>
-            <a:ext cx="3810000" cy="462280"/>
+            <a:off x="762000" y="2296160"/>
+            <a:ext cx="3810000" cy="497839"/>
           </a:xfrm>
           <a:prstGeom prst="rect">
             <a:avLst/>
@@ -18589,8 +18628,8 @@
         </p:nvSpPr>
         <p:spPr>
           <a:xfrm>
-            <a:off x="762000" y="2781300"/>
-            <a:ext cx="3810000" cy="462280"/>
+            <a:off x="762000" y="2857500"/>
+            <a:ext cx="3810000" cy="497839"/>
           </a:xfrm>
           <a:prstGeom prst="rect">
             <a:avLst/>
@@ -18628,8 +18667,8 @@
         </p:nvSpPr>
         <p:spPr>
           <a:xfrm>
-            <a:off x="762000" y="3332480"/>
-            <a:ext cx="3810000" cy="462280"/>
+            <a:off x="762000" y="3418840"/>
+            <a:ext cx="3810000" cy="497839"/>
           </a:xfrm>
           <a:prstGeom prst="rect">
             <a:avLst/>
@@ -18667,8 +18706,8 @@
         </p:nvSpPr>
         <p:spPr>
           <a:xfrm>
-            <a:off x="762000" y="3883660"/>
-            <a:ext cx="3810000" cy="462280"/>
+            <a:off x="762000" y="3980179"/>
+            <a:ext cx="3810000" cy="497839"/>
           </a:xfrm>
           <a:prstGeom prst="rect">
             <a:avLst/>
@@ -18706,8 +18745,8 @@
         </p:nvSpPr>
         <p:spPr>
           <a:xfrm>
-            <a:off x="762000" y="4434840"/>
-            <a:ext cx="3810000" cy="462280"/>
+            <a:off x="762000" y="4541520"/>
+            <a:ext cx="3810000" cy="497839"/>
           </a:xfrm>
           <a:prstGeom prst="rect">
             <a:avLst/>
@@ -18745,8 +18784,8 @@
         </p:nvSpPr>
         <p:spPr>
           <a:xfrm>
-            <a:off x="762000" y="4986020"/>
-            <a:ext cx="3810000" cy="462280"/>
+            <a:off x="762000" y="5102859"/>
+            <a:ext cx="3810000" cy="497839"/>
           </a:xfrm>
           <a:prstGeom prst="rect">
             <a:avLst/>
@@ -18951,7 +18990,7 @@
                 </a:solidFill>
                 <a:latin typeface="IBM Plex Mono"/>
               </a:rPr>
-              <a:t>source: data/interim/pages.csv, page_brand_counts.csv</a:t>
+              <a:t>source: data/interim/pages.csv, page_brand_counts.csv  ·  n = 243 pages</a:t>
             </a:r>
           </a:p>
         </p:txBody>

</xml_diff>